<commit_message>
Add 7th slide for references, split from executive summary
- Executive Summary now standalone on slide 6
- References + Thank You on new slide 7
- PPTX regenerated with matching 7-slide structure
- Fixed TOTAL_SLIDES (7) and container width (700vw)

Co-Authored-By: Claude Opus 4.6 (1M context) <noreply@anthropic.com>
</commit_message>
<xml_diff>
--- a/Tesla_Model3_Marketing.pptx
+++ b/Tesla_Model3_Marketing.pptx
@@ -11,9 +11,10 @@
     <p:sldId id="259" r:id="rId5"/>
     <p:sldId id="260" r:id="rId6"/>
     <p:sldId id="261" r:id="rId7"/>
+    <p:sldId id="262" r:id="rId8"/>
   </p:sldIdLst>
   <p:notesMasterIdLst>
-    <p:notesMasterId r:id="rId8"/>
+    <p:notesMasterId r:id="rId9"/>
   </p:notesMasterIdLst>
   <p:sldSz cx="9144000" cy="5143500"/>
   <p:notesSz cx="5143500" cy="9144000"/>
@@ -971,6 +972,94 @@
             <a:fld id="{F7021451-1387-4CA6-816F-3879F97B5CBC}" type="slidenum">
               <a:rPr lang="en-US"/>
               <a:t>6</a:t>
+            </a:fld>
+            <a:endParaRPr lang="en-US"/>
+          </a:p>
+        </p:txBody>
+      </p:sp>
+    </p:spTree>
+    <p:extLst>
+      <p:ext uri="{BB962C8B-B14F-4D97-AF65-F5344CB8AC3E}">
+        <p14:creationId xmlns:p14="http://schemas.microsoft.com/office/powerpoint/2010/main" val="1024086991"/>
+      </p:ext>
+    </p:extLst>
+  </p:cSld>
+  <p:clrMapOvr>
+    <a:masterClrMapping/>
+  </p:clrMapOvr>
+</p:notes>
+</file>
+
+<file path=ppt/notesSlides/notesSlide7.xml><?xml version="1.0" encoding="utf-8"?>
+<p:notes xmlns:a="http://schemas.openxmlformats.org/drawingml/2006/main" xmlns:r="http://schemas.openxmlformats.org/officeDocument/2006/relationships" xmlns:p="http://schemas.openxmlformats.org/presentationml/2006/main">
+  <p:cSld>
+    <p:spTree>
+      <p:nvGrpSpPr>
+        <p:cNvPr id="1" name=""/>
+        <p:cNvGrpSpPr/>
+        <p:nvPr/>
+      </p:nvGrpSpPr>
+      <p:grpSpPr>
+        <a:xfrm>
+          <a:off x="0" y="0"/>
+          <a:ext cx="0" cy="0"/>
+          <a:chOff x="0" y="0"/>
+          <a:chExt cx="0" cy="0"/>
+        </a:xfrm>
+      </p:grpSpPr>
+      <p:sp>
+        <p:nvSpPr>
+          <p:cNvPr id="2" name="Slide Image Placeholder 1"/>
+          <p:cNvSpPr>
+            <a:spLocks noGrp="1" noRot="1" noChangeAspect="1"/>
+          </p:cNvSpPr>
+          <p:nvPr>
+            <p:ph type="sldImg"/>
+          </p:nvPr>
+        </p:nvSpPr>
+        <p:spPr/>
+      </p:sp>
+      <p:sp>
+        <p:nvSpPr>
+          <p:cNvPr id="3" name="Notes Placeholder 2"/>
+          <p:cNvSpPr>
+            <a:spLocks noGrp="1"/>
+          </p:cNvSpPr>
+          <p:nvPr>
+            <p:ph type="body" idx="1"/>
+          </p:nvPr>
+        </p:nvSpPr>
+        <p:spPr/>
+        <p:txBody>
+          <a:bodyPr/>
+          <a:lstStyle/>
+          <a:p>
+            <a:r>
+              <a:rPr lang="en-US" dirty="0"/>
+              <a:t/>
+            </a:r>
+            <a:endParaRPr lang="en-US" dirty="0"/>
+          </a:p>
+        </p:txBody>
+      </p:sp>
+      <p:sp>
+        <p:nvSpPr>
+          <p:cNvPr id="4" name="Slide Number Placeholder 3"/>
+          <p:cNvSpPr>
+            <a:spLocks noGrp="1"/>
+          </p:cNvSpPr>
+          <p:nvPr>
+            <p:ph type="sldNum" sz="quarter" idx="10"/>
+          </p:nvPr>
+        </p:nvSpPr>
+        <p:spPr/>
+        <p:txBody>
+          <a:bodyPr/>
+          <a:lstStyle/>
+          <a:p>
+            <a:fld id="{F7021451-1387-4CA6-816F-3879F97B5CBC}" type="slidenum">
+              <a:rPr lang="en-US"/>
+              <a:t>7</a:t>
             </a:fld>
             <a:endParaRPr lang="en-US"/>
           </a:p>
@@ -8169,34 +8258,14 @@
       </p:sp>
       <p:sp>
         <p:nvSpPr>
-          <p:cNvPr id="3" name="Shape 1"/>
-          <p:cNvSpPr/>
-          <p:nvPr/>
-        </p:nvSpPr>
-        <p:spPr>
-          <a:xfrm>
-            <a:off x="0" y="5116068"/>
-            <a:ext cx="9144000" cy="27432"/>
-          </a:xfrm>
-          <a:prstGeom prst="rect">
-            <a:avLst/>
-          </a:prstGeom>
-          <a:solidFill>
-            <a:srgbClr val="E82127"/>
-          </a:solidFill>
-          <a:ln/>
-        </p:spPr>
-      </p:sp>
-      <p:sp>
-        <p:nvSpPr>
-          <p:cNvPr id="4" name="Text 2"/>
-          <p:cNvSpPr/>
-          <p:nvPr/>
-        </p:nvSpPr>
-        <p:spPr>
-          <a:xfrm>
-            <a:off x="457200" y="365760"/>
-            <a:ext cx="8229600" cy="457200"/>
+          <p:cNvPr id="3" name="Text 1"/>
+          <p:cNvSpPr/>
+          <p:nvPr/>
+        </p:nvSpPr>
+        <p:spPr>
+          <a:xfrm>
+            <a:off x="457200" y="137160"/>
+            <a:ext cx="731520" cy="502920"/>
           </a:xfrm>
           <a:prstGeom prst="rect">
             <a:avLst/>
@@ -8208,11 +8277,50 @@
           <a:bodyPr wrap="square" lIns="0" tIns="0" rIns="0" bIns="0" rtlCol="0" anchor="ctr"/>
           <a:lstStyle/>
           <a:p>
-            <a:pPr algn="ctr" indent="0" marL="0">
+            <a:pPr indent="0" marL="0">
               <a:buNone/>
             </a:pPr>
             <a:r>
-              <a:rPr lang="en-US" sz="2400" dirty="0">
+              <a:rPr lang="en-US" sz="2800" dirty="0">
+                <a:solidFill>
+                  <a:srgbClr val="E82127"/>
+                </a:solidFill>
+                <a:latin typeface="Arial Black" pitchFamily="34" charset="0"/>
+                <a:ea typeface="Arial Black" pitchFamily="34" charset="-122"/>
+                <a:cs typeface="Arial Black" pitchFamily="34" charset="-120"/>
+              </a:rPr>
+              <a:t>05</a:t>
+            </a:r>
+            <a:endParaRPr lang="en-US" sz="2800" dirty="0"/>
+          </a:p>
+        </p:txBody>
+      </p:sp>
+      <p:sp>
+        <p:nvSpPr>
+          <p:cNvPr id="4" name="Text 2"/>
+          <p:cNvSpPr/>
+          <p:nvPr/>
+        </p:nvSpPr>
+        <p:spPr>
+          <a:xfrm>
+            <a:off x="457200" y="502920"/>
+            <a:ext cx="8229600" cy="411480"/>
+          </a:xfrm>
+          <a:prstGeom prst="rect">
+            <a:avLst/>
+          </a:prstGeom>
+          <a:noFill/>
+          <a:ln/>
+        </p:spPr>
+        <p:txBody>
+          <a:bodyPr wrap="square" lIns="0" tIns="0" rIns="0" bIns="0" rtlCol="0" anchor="ctr"/>
+          <a:lstStyle/>
+          <a:p>
+            <a:pPr indent="0" marL="0">
+              <a:buNone/>
+            </a:pPr>
+            <a:r>
+              <a:rPr lang="en-US" sz="2200" dirty="0">
                 <a:solidFill>
                   <a:srgbClr val="F0F0F0"/>
                 </a:solidFill>
@@ -8222,20 +8330,67 @@
               </a:rPr>
               <a:t>Executive Summary</a:t>
             </a:r>
-            <a:endParaRPr lang="en-US" sz="2400" dirty="0"/>
-          </a:p>
-        </p:txBody>
-      </p:sp>
-      <p:sp>
-        <p:nvSpPr>
-          <p:cNvPr id="5" name="Text 3"/>
-          <p:cNvSpPr/>
-          <p:nvPr/>
-        </p:nvSpPr>
-        <p:spPr>
-          <a:xfrm>
-            <a:off x="914400" y="960120"/>
-            <a:ext cx="7315200" cy="365760"/>
+            <a:endParaRPr lang="en-US" sz="2200" dirty="0"/>
+          </a:p>
+        </p:txBody>
+      </p:sp>
+      <p:sp>
+        <p:nvSpPr>
+          <p:cNvPr id="5" name="Shape 3"/>
+          <p:cNvSpPr/>
+          <p:nvPr/>
+        </p:nvSpPr>
+        <p:spPr>
+          <a:xfrm>
+            <a:off x="457200" y="1188720"/>
+            <a:ext cx="8229600" cy="3657600"/>
+          </a:xfrm>
+          <a:prstGeom prst="rect">
+            <a:avLst/>
+          </a:prstGeom>
+          <a:solidFill>
+            <a:srgbClr val="141420"/>
+          </a:solidFill>
+          <a:ln/>
+          <a:effectLst>
+            <a:outerShdw sx="100000" sy="100000" kx="0" ky="0" algn="bl" rotWithShape="0" blurRad="76200" dist="25400" dir="8100000">
+              <a:srgbClr val="000000">
+                <a:alpha val="35000"/>
+              </a:srgbClr>
+            </a:outerShdw>
+          </a:effectLst>
+        </p:spPr>
+      </p:sp>
+      <p:sp>
+        <p:nvSpPr>
+          <p:cNvPr id="6" name="Shape 4"/>
+          <p:cNvSpPr/>
+          <p:nvPr/>
+        </p:nvSpPr>
+        <p:spPr>
+          <a:xfrm>
+            <a:off x="457200" y="1188720"/>
+            <a:ext cx="8229600" cy="32004"/>
+          </a:xfrm>
+          <a:prstGeom prst="rect">
+            <a:avLst/>
+          </a:prstGeom>
+          <a:solidFill>
+            <a:srgbClr val="E82127"/>
+          </a:solidFill>
+          <a:ln/>
+        </p:spPr>
+      </p:sp>
+      <p:sp>
+        <p:nvSpPr>
+          <p:cNvPr id="7" name="Text 5"/>
+          <p:cNvSpPr/>
+          <p:nvPr/>
+        </p:nvSpPr>
+        <p:spPr>
+          <a:xfrm>
+            <a:off x="594360" y="1280160"/>
+            <a:ext cx="3657600" cy="201168"/>
           </a:xfrm>
           <a:prstGeom prst="rect">
             <a:avLst/>
@@ -8255,12 +8410,37 @@
                 <a:solidFill>
                   <a:srgbClr val="E82127"/>
                 </a:solidFill>
-                <a:latin typeface="Arial Black" pitchFamily="34" charset="0"/>
-                <a:ea typeface="Arial Black" pitchFamily="34" charset="-122"/>
-                <a:cs typeface="Arial Black" pitchFamily="34" charset="-120"/>
+                <a:latin typeface="Arial" pitchFamily="34" charset="0"/>
+                <a:ea typeface="Arial" pitchFamily="34" charset="-122"/>
+                <a:cs typeface="Arial" pitchFamily="34" charset="-120"/>
               </a:rPr>
-              <a:t>01  </a:t>
-            </a:r>
+              <a:t>Executive Summary</a:t>
+            </a:r>
+            <a:endParaRPr lang="en-US" sz="1000" dirty="0"/>
+          </a:p>
+        </p:txBody>
+      </p:sp>
+      <p:sp>
+        <p:nvSpPr>
+          <p:cNvPr id="8" name="Text 6"/>
+          <p:cNvSpPr/>
+          <p:nvPr/>
+        </p:nvSpPr>
+        <p:spPr>
+          <a:xfrm>
+            <a:off x="594360" y="1554480"/>
+            <a:ext cx="7955280" cy="3108960"/>
+          </a:xfrm>
+          <a:prstGeom prst="rect">
+            <a:avLst/>
+          </a:prstGeom>
+          <a:noFill/>
+          <a:ln/>
+        </p:spPr>
+        <p:txBody>
+          <a:bodyPr wrap="square" lIns="0" tIns="0" rIns="0" bIns="0" rtlCol="0" anchor="ctr"/>
+          <a:lstStyle/>
+          <a:p>
             <a:pPr indent="0" marL="0">
               <a:buNone/>
             </a:pPr>
@@ -8275,20 +8455,92 @@
               </a:rPr>
               <a:t>(content to be added)</a:t>
             </a:r>
-            <a:endParaRPr lang="en-US" sz="1000" dirty="0"/>
-          </a:p>
-        </p:txBody>
-      </p:sp>
-      <p:sp>
-        <p:nvSpPr>
-          <p:cNvPr id="6" name="Text 4"/>
-          <p:cNvSpPr/>
-          <p:nvPr/>
-        </p:nvSpPr>
-        <p:spPr>
-          <a:xfrm>
-            <a:off x="914400" y="1371600"/>
-            <a:ext cx="7315200" cy="365760"/>
+            <a:endParaRPr lang="en-US" sz="900" dirty="0"/>
+          </a:p>
+        </p:txBody>
+      </p:sp>
+    </p:spTree>
+  </p:cSld>
+  <p:clrMapOvr>
+    <a:masterClrMapping/>
+  </p:clrMapOvr>
+</p:sld>
+</file>
+
+<file path=ppt/slides/slide7.xml><?xml version="1.0" encoding="utf-8"?>
+<p:sld xmlns:a="http://schemas.openxmlformats.org/drawingml/2006/main" xmlns:r="http://schemas.openxmlformats.org/officeDocument/2006/relationships" xmlns:p="http://schemas.openxmlformats.org/presentationml/2006/main">
+  <p:cSld name="Slide 7">
+    <p:bg>
+      <p:bgPr>
+        <a:solidFill>
+          <a:srgbClr val="0A0A0F"/>
+        </a:solidFill>
+      </p:bgPr>
+    </p:bg>
+    <p:spTree>
+      <p:nvGrpSpPr>
+        <p:cNvPr id="1" name=""/>
+        <p:cNvGrpSpPr/>
+        <p:nvPr/>
+      </p:nvGrpSpPr>
+      <p:grpSpPr>
+        <a:xfrm>
+          <a:off x="0" y="0"/>
+          <a:ext cx="0" cy="0"/>
+          <a:chOff x="0" y="0"/>
+          <a:chExt cx="0" cy="0"/>
+        </a:xfrm>
+      </p:grpSpPr>
+      <p:sp>
+        <p:nvSpPr>
+          <p:cNvPr id="2" name="Shape 0"/>
+          <p:cNvSpPr/>
+          <p:nvPr/>
+        </p:nvSpPr>
+        <p:spPr>
+          <a:xfrm>
+            <a:off x="0" y="0"/>
+            <a:ext cx="9144000" cy="27432"/>
+          </a:xfrm>
+          <a:prstGeom prst="rect">
+            <a:avLst/>
+          </a:prstGeom>
+          <a:solidFill>
+            <a:srgbClr val="E82127"/>
+          </a:solidFill>
+          <a:ln/>
+        </p:spPr>
+      </p:sp>
+      <p:sp>
+        <p:nvSpPr>
+          <p:cNvPr id="3" name="Shape 1"/>
+          <p:cNvSpPr/>
+          <p:nvPr/>
+        </p:nvSpPr>
+        <p:spPr>
+          <a:xfrm>
+            <a:off x="0" y="5116068"/>
+            <a:ext cx="9144000" cy="27432"/>
+          </a:xfrm>
+          <a:prstGeom prst="rect">
+            <a:avLst/>
+          </a:prstGeom>
+          <a:solidFill>
+            <a:srgbClr val="E82127"/>
+          </a:solidFill>
+          <a:ln/>
+        </p:spPr>
+      </p:sp>
+      <p:sp>
+        <p:nvSpPr>
+          <p:cNvPr id="4" name="Text 2"/>
+          <p:cNvSpPr/>
+          <p:nvPr/>
+        </p:nvSpPr>
+        <p:spPr>
+          <a:xfrm>
+            <a:off x="457200" y="137160"/>
+            <a:ext cx="731520" cy="502920"/>
           </a:xfrm>
           <a:prstGeom prst="rect">
             <a:avLst/>
@@ -8304,7 +8556,7 @@
               <a:buNone/>
             </a:pPr>
             <a:r>
-              <a:rPr lang="en-US" sz="1000" b="1" dirty="0">
+              <a:rPr lang="en-US" sz="2800" dirty="0">
                 <a:solidFill>
                   <a:srgbClr val="E82127"/>
                 </a:solidFill>
@@ -8312,8 +8564,197 @@
                 <a:ea typeface="Arial Black" pitchFamily="34" charset="-122"/>
                 <a:cs typeface="Arial Black" pitchFamily="34" charset="-120"/>
               </a:rPr>
-              <a:t>02  </a:t>
-            </a:r>
+              <a:t>06</a:t>
+            </a:r>
+            <a:endParaRPr lang="en-US" sz="2800" dirty="0"/>
+          </a:p>
+        </p:txBody>
+      </p:sp>
+      <p:sp>
+        <p:nvSpPr>
+          <p:cNvPr id="5" name="Text 3"/>
+          <p:cNvSpPr/>
+          <p:nvPr/>
+        </p:nvSpPr>
+        <p:spPr>
+          <a:xfrm>
+            <a:off x="457200" y="502920"/>
+            <a:ext cx="8229600" cy="411480"/>
+          </a:xfrm>
+          <a:prstGeom prst="rect">
+            <a:avLst/>
+          </a:prstGeom>
+          <a:noFill/>
+          <a:ln/>
+        </p:spPr>
+        <p:txBody>
+          <a:bodyPr wrap="square" lIns="0" tIns="0" rIns="0" bIns="0" rtlCol="0" anchor="ctr"/>
+          <a:lstStyle/>
+          <a:p>
+            <a:pPr indent="0" marL="0">
+              <a:buNone/>
+            </a:pPr>
+            <a:r>
+              <a:rPr lang="en-US" sz="2200" dirty="0">
+                <a:solidFill>
+                  <a:srgbClr val="F0F0F0"/>
+                </a:solidFill>
+                <a:latin typeface="Arial Black" pitchFamily="34" charset="0"/>
+                <a:ea typeface="Arial Black" pitchFamily="34" charset="-122"/>
+                <a:cs typeface="Arial Black" pitchFamily="34" charset="-120"/>
+              </a:rPr>
+              <a:t>References</a:t>
+            </a:r>
+            <a:endParaRPr lang="en-US" sz="2200" dirty="0"/>
+          </a:p>
+        </p:txBody>
+      </p:sp>
+      <p:sp>
+        <p:nvSpPr>
+          <p:cNvPr id="6" name="Text 4"/>
+          <p:cNvSpPr/>
+          <p:nvPr/>
+        </p:nvSpPr>
+        <p:spPr>
+          <a:xfrm>
+            <a:off x="457200" y="868680"/>
+            <a:ext cx="7315200" cy="274320"/>
+          </a:xfrm>
+          <a:prstGeom prst="rect">
+            <a:avLst/>
+          </a:prstGeom>
+          <a:noFill/>
+          <a:ln/>
+        </p:spPr>
+        <p:txBody>
+          <a:bodyPr wrap="square" lIns="0" tIns="0" rIns="0" bIns="0" rtlCol="0" anchor="ctr"/>
+          <a:lstStyle/>
+          <a:p>
+            <a:pPr indent="0" marL="0">
+              <a:buNone/>
+            </a:pPr>
+            <a:r>
+              <a:rPr lang="en-US" sz="1000" i="1" dirty="0">
+                <a:solidFill>
+                  <a:srgbClr val="666677"/>
+                </a:solidFill>
+                <a:latin typeface="Georgia" pitchFamily="34" charset="0"/>
+                <a:ea typeface="Georgia" pitchFamily="34" charset="-122"/>
+                <a:cs typeface="Georgia" pitchFamily="34" charset="-120"/>
+              </a:rPr>
+              <a:t>Sources &amp; Citations</a:t>
+            </a:r>
+            <a:endParaRPr lang="en-US" sz="1000" dirty="0"/>
+          </a:p>
+        </p:txBody>
+      </p:sp>
+      <p:sp>
+        <p:nvSpPr>
+          <p:cNvPr id="7" name="Shape 5"/>
+          <p:cNvSpPr/>
+          <p:nvPr/>
+        </p:nvSpPr>
+        <p:spPr>
+          <a:xfrm>
+            <a:off x="457200" y="1188720"/>
+            <a:ext cx="8229600" cy="3200400"/>
+          </a:xfrm>
+          <a:prstGeom prst="rect">
+            <a:avLst/>
+          </a:prstGeom>
+          <a:solidFill>
+            <a:srgbClr val="141420"/>
+          </a:solidFill>
+          <a:ln/>
+          <a:effectLst>
+            <a:outerShdw sx="100000" sy="100000" kx="0" ky="0" algn="bl" rotWithShape="0" blurRad="76200" dist="25400" dir="8100000">
+              <a:srgbClr val="000000">
+                <a:alpha val="35000"/>
+              </a:srgbClr>
+            </a:outerShdw>
+          </a:effectLst>
+        </p:spPr>
+      </p:sp>
+      <p:sp>
+        <p:nvSpPr>
+          <p:cNvPr id="8" name="Shape 6"/>
+          <p:cNvSpPr/>
+          <p:nvPr/>
+        </p:nvSpPr>
+        <p:spPr>
+          <a:xfrm>
+            <a:off x="457200" y="1188720"/>
+            <a:ext cx="8229600" cy="32004"/>
+          </a:xfrm>
+          <a:prstGeom prst="rect">
+            <a:avLst/>
+          </a:prstGeom>
+          <a:solidFill>
+            <a:srgbClr val="E82127"/>
+          </a:solidFill>
+          <a:ln/>
+        </p:spPr>
+      </p:sp>
+      <p:sp>
+        <p:nvSpPr>
+          <p:cNvPr id="9" name="Text 7"/>
+          <p:cNvSpPr/>
+          <p:nvPr/>
+        </p:nvSpPr>
+        <p:spPr>
+          <a:xfrm>
+            <a:off x="594360" y="1280160"/>
+            <a:ext cx="3657600" cy="201168"/>
+          </a:xfrm>
+          <a:prstGeom prst="rect">
+            <a:avLst/>
+          </a:prstGeom>
+          <a:noFill/>
+          <a:ln/>
+        </p:spPr>
+        <p:txBody>
+          <a:bodyPr wrap="square" lIns="0" tIns="0" rIns="0" bIns="0" rtlCol="0" anchor="ctr"/>
+          <a:lstStyle/>
+          <a:p>
+            <a:pPr indent="0" marL="0">
+              <a:buNone/>
+            </a:pPr>
+            <a:r>
+              <a:rPr lang="en-US" sz="1000" b="1" dirty="0">
+                <a:solidFill>
+                  <a:srgbClr val="E82127"/>
+                </a:solidFill>
+                <a:latin typeface="Arial" pitchFamily="34" charset="0"/>
+                <a:ea typeface="Arial" pitchFamily="34" charset="-122"/>
+                <a:cs typeface="Arial" pitchFamily="34" charset="-120"/>
+              </a:rPr>
+              <a:t>References</a:t>
+            </a:r>
+            <a:endParaRPr lang="en-US" sz="1000" dirty="0"/>
+          </a:p>
+        </p:txBody>
+      </p:sp>
+      <p:sp>
+        <p:nvSpPr>
+          <p:cNvPr id="10" name="Text 8"/>
+          <p:cNvSpPr/>
+          <p:nvPr/>
+        </p:nvSpPr>
+        <p:spPr>
+          <a:xfrm>
+            <a:off x="594360" y="1554480"/>
+            <a:ext cx="7955280" cy="2651760"/>
+          </a:xfrm>
+          <a:prstGeom prst="rect">
+            <a:avLst/>
+          </a:prstGeom>
+          <a:noFill/>
+          <a:ln/>
+        </p:spPr>
+        <p:txBody>
+          <a:bodyPr wrap="square" lIns="0" tIns="0" rIns="0" bIns="0" rtlCol="0" anchor="ctr"/>
+          <a:lstStyle/>
+          <a:p>
             <a:pPr indent="0" marL="0">
               <a:buNone/>
             </a:pPr>
@@ -8328,219 +8769,7 @@
               </a:rPr>
               <a:t>(content to be added)</a:t>
             </a:r>
-            <a:endParaRPr lang="en-US" sz="1000" dirty="0"/>
-          </a:p>
-        </p:txBody>
-      </p:sp>
-      <p:sp>
-        <p:nvSpPr>
-          <p:cNvPr id="7" name="Text 5"/>
-          <p:cNvSpPr/>
-          <p:nvPr/>
-        </p:nvSpPr>
-        <p:spPr>
-          <a:xfrm>
-            <a:off x="914400" y="1783080"/>
-            <a:ext cx="7315200" cy="365760"/>
-          </a:xfrm>
-          <a:prstGeom prst="rect">
-            <a:avLst/>
-          </a:prstGeom>
-          <a:noFill/>
-          <a:ln/>
-        </p:spPr>
-        <p:txBody>
-          <a:bodyPr wrap="square" lIns="0" tIns="0" rIns="0" bIns="0" rtlCol="0" anchor="ctr"/>
-          <a:lstStyle/>
-          <a:p>
-            <a:pPr indent="0" marL="0">
-              <a:buNone/>
-            </a:pPr>
-            <a:r>
-              <a:rPr lang="en-US" sz="1000" b="1" dirty="0">
-                <a:solidFill>
-                  <a:srgbClr val="E82127"/>
-                </a:solidFill>
-                <a:latin typeface="Arial Black" pitchFamily="34" charset="0"/>
-                <a:ea typeface="Arial Black" pitchFamily="34" charset="-122"/>
-                <a:cs typeface="Arial Black" pitchFamily="34" charset="-120"/>
-              </a:rPr>
-              <a:t>03  </a:t>
-            </a:r>
-            <a:pPr indent="0" marL="0">
-              <a:buNone/>
-            </a:pPr>
-            <a:r>
-              <a:rPr lang="en-US" sz="900" dirty="0">
-                <a:solidFill>
-                  <a:srgbClr val="666677"/>
-                </a:solidFill>
-                <a:latin typeface="Arial" pitchFamily="34" charset="0"/>
-                <a:ea typeface="Arial" pitchFamily="34" charset="-122"/>
-                <a:cs typeface="Arial" pitchFamily="34" charset="-120"/>
-              </a:rPr>
-              <a:t>(content to be added)</a:t>
-            </a:r>
-            <a:endParaRPr lang="en-US" sz="1000" dirty="0"/>
-          </a:p>
-        </p:txBody>
-      </p:sp>
-      <p:sp>
-        <p:nvSpPr>
-          <p:cNvPr id="8" name="Text 6"/>
-          <p:cNvSpPr/>
-          <p:nvPr/>
-        </p:nvSpPr>
-        <p:spPr>
-          <a:xfrm>
-            <a:off x="914400" y="2194560"/>
-            <a:ext cx="7315200" cy="365760"/>
-          </a:xfrm>
-          <a:prstGeom prst="rect">
-            <a:avLst/>
-          </a:prstGeom>
-          <a:noFill/>
-          <a:ln/>
-        </p:spPr>
-        <p:txBody>
-          <a:bodyPr wrap="square" lIns="0" tIns="0" rIns="0" bIns="0" rtlCol="0" anchor="ctr"/>
-          <a:lstStyle/>
-          <a:p>
-            <a:pPr indent="0" marL="0">
-              <a:buNone/>
-            </a:pPr>
-            <a:r>
-              <a:rPr lang="en-US" sz="1000" b="1" dirty="0">
-                <a:solidFill>
-                  <a:srgbClr val="E82127"/>
-                </a:solidFill>
-                <a:latin typeface="Arial Black" pitchFamily="34" charset="0"/>
-                <a:ea typeface="Arial Black" pitchFamily="34" charset="-122"/>
-                <a:cs typeface="Arial Black" pitchFamily="34" charset="-120"/>
-              </a:rPr>
-              <a:t>04  </a:t>
-            </a:r>
-            <a:pPr indent="0" marL="0">
-              <a:buNone/>
-            </a:pPr>
-            <a:r>
-              <a:rPr lang="en-US" sz="900" dirty="0">
-                <a:solidFill>
-                  <a:srgbClr val="666677"/>
-                </a:solidFill>
-                <a:latin typeface="Arial" pitchFamily="34" charset="0"/>
-                <a:ea typeface="Arial" pitchFamily="34" charset="-122"/>
-                <a:cs typeface="Arial" pitchFamily="34" charset="-120"/>
-              </a:rPr>
-              <a:t>(content to be added)</a:t>
-            </a:r>
-            <a:endParaRPr lang="en-US" sz="1000" dirty="0"/>
-          </a:p>
-        </p:txBody>
-      </p:sp>
-      <p:sp>
-        <p:nvSpPr>
-          <p:cNvPr id="9" name="Text 7"/>
-          <p:cNvSpPr/>
-          <p:nvPr/>
-        </p:nvSpPr>
-        <p:spPr>
-          <a:xfrm>
-            <a:off x="914400" y="2606040"/>
-            <a:ext cx="7315200" cy="365760"/>
-          </a:xfrm>
-          <a:prstGeom prst="rect">
-            <a:avLst/>
-          </a:prstGeom>
-          <a:noFill/>
-          <a:ln/>
-        </p:spPr>
-        <p:txBody>
-          <a:bodyPr wrap="square" lIns="0" tIns="0" rIns="0" bIns="0" rtlCol="0" anchor="ctr"/>
-          <a:lstStyle/>
-          <a:p>
-            <a:pPr indent="0" marL="0">
-              <a:buNone/>
-            </a:pPr>
-            <a:r>
-              <a:rPr lang="en-US" sz="1000" b="1" dirty="0">
-                <a:solidFill>
-                  <a:srgbClr val="E82127"/>
-                </a:solidFill>
-                <a:latin typeface="Arial Black" pitchFamily="34" charset="0"/>
-                <a:ea typeface="Arial Black" pitchFamily="34" charset="-122"/>
-                <a:cs typeface="Arial Black" pitchFamily="34" charset="-120"/>
-              </a:rPr>
-              <a:t>05  </a:t>
-            </a:r>
-            <a:pPr indent="0" marL="0">
-              <a:buNone/>
-            </a:pPr>
-            <a:r>
-              <a:rPr lang="en-US" sz="900" dirty="0">
-                <a:solidFill>
-                  <a:srgbClr val="666677"/>
-                </a:solidFill>
-                <a:latin typeface="Arial" pitchFamily="34" charset="0"/>
-                <a:ea typeface="Arial" pitchFamily="34" charset="-122"/>
-                <a:cs typeface="Arial" pitchFamily="34" charset="-120"/>
-              </a:rPr>
-              <a:t>(content to be added)</a:t>
-            </a:r>
-            <a:endParaRPr lang="en-US" sz="1000" dirty="0"/>
-          </a:p>
-        </p:txBody>
-      </p:sp>
-      <p:sp>
-        <p:nvSpPr>
-          <p:cNvPr id="10" name="Text 8"/>
-          <p:cNvSpPr/>
-          <p:nvPr/>
-        </p:nvSpPr>
-        <p:spPr>
-          <a:xfrm>
-            <a:off x="914400" y="3017520"/>
-            <a:ext cx="7315200" cy="365760"/>
-          </a:xfrm>
-          <a:prstGeom prst="rect">
-            <a:avLst/>
-          </a:prstGeom>
-          <a:noFill/>
-          <a:ln/>
-        </p:spPr>
-        <p:txBody>
-          <a:bodyPr wrap="square" lIns="0" tIns="0" rIns="0" bIns="0" rtlCol="0" anchor="ctr"/>
-          <a:lstStyle/>
-          <a:p>
-            <a:pPr indent="0" marL="0">
-              <a:buNone/>
-            </a:pPr>
-            <a:r>
-              <a:rPr lang="en-US" sz="1000" b="1" dirty="0">
-                <a:solidFill>
-                  <a:srgbClr val="E82127"/>
-                </a:solidFill>
-                <a:latin typeface="Arial Black" pitchFamily="34" charset="0"/>
-                <a:ea typeface="Arial Black" pitchFamily="34" charset="-122"/>
-                <a:cs typeface="Arial Black" pitchFamily="34" charset="-120"/>
-              </a:rPr>
-              <a:t>06  </a:t>
-            </a:r>
-            <a:pPr indent="0" marL="0">
-              <a:buNone/>
-            </a:pPr>
-            <a:r>
-              <a:rPr lang="en-US" sz="900" dirty="0">
-                <a:solidFill>
-                  <a:srgbClr val="666677"/>
-                </a:solidFill>
-                <a:latin typeface="Arial" pitchFamily="34" charset="0"/>
-                <a:ea typeface="Arial" pitchFamily="34" charset="-122"/>
-                <a:cs typeface="Arial" pitchFamily="34" charset="-120"/>
-              </a:rPr>
-              <a:t>(content to be added)</a:t>
-            </a:r>
-            <a:endParaRPr lang="en-US" sz="1000" dirty="0"/>
+            <a:endParaRPr lang="en-US" sz="900" dirty="0"/>
           </a:p>
         </p:txBody>
       </p:sp>
@@ -8552,159 +8781,8 @@
         </p:nvSpPr>
         <p:spPr>
           <a:xfrm>
-            <a:off x="914400" y="3429000"/>
-            <a:ext cx="7315200" cy="365760"/>
-          </a:xfrm>
-          <a:prstGeom prst="rect">
-            <a:avLst/>
-          </a:prstGeom>
-          <a:noFill/>
-          <a:ln/>
-        </p:spPr>
-        <p:txBody>
-          <a:bodyPr wrap="square" lIns="0" tIns="0" rIns="0" bIns="0" rtlCol="0" anchor="ctr"/>
-          <a:lstStyle/>
-          <a:p>
-            <a:pPr indent="0" marL="0">
-              <a:buNone/>
-            </a:pPr>
-            <a:r>
-              <a:rPr lang="en-US" sz="1000" b="1" dirty="0">
-                <a:solidFill>
-                  <a:srgbClr val="E82127"/>
-                </a:solidFill>
-                <a:latin typeface="Arial Black" pitchFamily="34" charset="0"/>
-                <a:ea typeface="Arial Black" pitchFamily="34" charset="-122"/>
-                <a:cs typeface="Arial Black" pitchFamily="34" charset="-120"/>
-              </a:rPr>
-              <a:t>07  </a:t>
-            </a:r>
-            <a:pPr indent="0" marL="0">
-              <a:buNone/>
-            </a:pPr>
-            <a:r>
-              <a:rPr lang="en-US" sz="900" dirty="0">
-                <a:solidFill>
-                  <a:srgbClr val="666677"/>
-                </a:solidFill>
-                <a:latin typeface="Arial" pitchFamily="34" charset="0"/>
-                <a:ea typeface="Arial" pitchFamily="34" charset="-122"/>
-                <a:cs typeface="Arial" pitchFamily="34" charset="-120"/>
-              </a:rPr>
-              <a:t>(content to be added)</a:t>
-            </a:r>
-            <a:endParaRPr lang="en-US" sz="1000" dirty="0"/>
-          </a:p>
-        </p:txBody>
-      </p:sp>
-      <p:sp>
-        <p:nvSpPr>
-          <p:cNvPr id="12" name="Shape 10"/>
-          <p:cNvSpPr/>
-          <p:nvPr/>
-        </p:nvSpPr>
-        <p:spPr>
-          <a:xfrm>
-            <a:off x="457200" y="3931920"/>
-            <a:ext cx="8229600" cy="27432"/>
-          </a:xfrm>
-          <a:prstGeom prst="rect">
-            <a:avLst/>
-          </a:prstGeom>
-          <a:solidFill>
-            <a:srgbClr val="2A2A3A"/>
-          </a:solidFill>
-          <a:ln/>
-        </p:spPr>
-      </p:sp>
-      <p:sp>
-        <p:nvSpPr>
-          <p:cNvPr id="13" name="Text 11"/>
-          <p:cNvSpPr/>
-          <p:nvPr/>
-        </p:nvSpPr>
-        <p:spPr>
-          <a:xfrm>
-            <a:off x="457200" y="4005072"/>
-            <a:ext cx="2743200" cy="182880"/>
-          </a:xfrm>
-          <a:prstGeom prst="rect">
-            <a:avLst/>
-          </a:prstGeom>
-          <a:noFill/>
-          <a:ln/>
-        </p:spPr>
-        <p:txBody>
-          <a:bodyPr wrap="square" lIns="0" tIns="0" rIns="0" bIns="0" rtlCol="0" anchor="ctr"/>
-          <a:lstStyle/>
-          <a:p>
-            <a:pPr indent="0" marL="0">
-              <a:buNone/>
-            </a:pPr>
-            <a:r>
-              <a:rPr lang="en-US" sz="800" b="1" spc="300" kern="0" dirty="0">
-                <a:solidFill>
-                  <a:srgbClr val="E82127"/>
-                </a:solidFill>
-                <a:latin typeface="Arial" pitchFamily="34" charset="0"/>
-                <a:ea typeface="Arial" pitchFamily="34" charset="-122"/>
-                <a:cs typeface="Arial" pitchFamily="34" charset="-120"/>
-              </a:rPr>
-              <a:t>REFERENCES</a:t>
-            </a:r>
-            <a:endParaRPr lang="en-US" sz="800" dirty="0"/>
-          </a:p>
-        </p:txBody>
-      </p:sp>
-      <p:sp>
-        <p:nvSpPr>
-          <p:cNvPr id="14" name="Text 12"/>
-          <p:cNvSpPr/>
-          <p:nvPr/>
-        </p:nvSpPr>
-        <p:spPr>
-          <a:xfrm>
-            <a:off x="457200" y="4206240"/>
-            <a:ext cx="8229600" cy="502920"/>
-          </a:xfrm>
-          <a:prstGeom prst="rect">
-            <a:avLst/>
-          </a:prstGeom>
-          <a:noFill/>
-          <a:ln/>
-        </p:spPr>
-        <p:txBody>
-          <a:bodyPr wrap="square" lIns="0" tIns="0" rIns="0" bIns="0" rtlCol="0" anchor="ctr"/>
-          <a:lstStyle/>
-          <a:p>
-            <a:pPr indent="0" marL="0">
-              <a:buNone/>
-            </a:pPr>
-            <a:r>
-              <a:rPr lang="en-US" sz="700" dirty="0">
-                <a:solidFill>
-                  <a:srgbClr val="666677"/>
-                </a:solidFill>
-                <a:latin typeface="Arial" pitchFamily="34" charset="0"/>
-                <a:ea typeface="Arial" pitchFamily="34" charset="-122"/>
-                <a:cs typeface="Arial" pitchFamily="34" charset="-120"/>
-              </a:rPr>
-              <a:t>(content to be added)</a:t>
-            </a:r>
-            <a:endParaRPr lang="en-US" sz="700" dirty="0"/>
-          </a:p>
-        </p:txBody>
-      </p:sp>
-      <p:sp>
-        <p:nvSpPr>
-          <p:cNvPr id="15" name="Text 13"/>
-          <p:cNvSpPr/>
-          <p:nvPr/>
-        </p:nvSpPr>
-        <p:spPr>
-          <a:xfrm>
-            <a:off x="0" y="4754880"/>
-            <a:ext cx="9144000" cy="274320"/>
+            <a:off x="0" y="4663440"/>
+            <a:ext cx="9144000" cy="320040"/>
           </a:xfrm>
           <a:prstGeom prst="rect">
             <a:avLst/>
@@ -8720,7 +8798,7 @@
               <a:buNone/>
             </a:pPr>
             <a:r>
-              <a:rPr lang="en-US" sz="1600" dirty="0">
+              <a:rPr lang="en-US" sz="1800" dirty="0">
                 <a:solidFill>
                   <a:srgbClr val="E82127"/>
                 </a:solidFill>
@@ -8730,7 +8808,7 @@
               </a:rPr>
               <a:t>Thank You</a:t>
             </a:r>
-            <a:endParaRPr lang="en-US" sz="1600" dirty="0"/>
+            <a:endParaRPr lang="en-US" sz="1800" dirty="0"/>
           </a:p>
         </p:txBody>
       </p:sp>

</xml_diff>

<commit_message>
Sync website with PPTX content — 4Ps, PESTEL impacts, 6 slides
- Copied all user-edited PPTX content to website
- Converted 7Ps to 4Ps (removed People/Process/Physical Evidence)
- Filled PESTEL impact ratings (Political: High, Economic: Moderate, etc.)
- Removed Executive Summary slide — now 6 slides total
- Porter's Five Forces with levels and analysis
- SWOT with actual content
- All card placeholders replaced with real bullet points

Co-Authored-By: Claude Opus 4.6 (1M context) <noreply@anthropic.com>
</commit_message>
<xml_diff>
--- a/Tesla_Model3_Marketing.pptx
+++ b/Tesla_Model3_Marketing.pptx
@@ -11,10 +11,9 @@
     <p:sldId id="259" r:id="rId5"/>
     <p:sldId id="260" r:id="rId6"/>
     <p:sldId id="261" r:id="rId7"/>
-    <p:sldId id="262" r:id="rId8"/>
   </p:sldIdLst>
   <p:notesMasterIdLst>
-    <p:notesMasterId r:id="rId9"/>
+    <p:notesMasterId r:id="rId8"/>
   </p:notesMasterIdLst>
   <p:sldSz cx="9144000" cy="5143500"/>
   <p:notesSz cx="5143500" cy="9144000"/>
@@ -972,94 +971,6 @@
             <a:fld id="{F7021451-1387-4CA6-816F-3879F97B5CBC}" type="slidenum">
               <a:rPr lang="en-US"/>
               <a:t>6</a:t>
-            </a:fld>
-            <a:endParaRPr lang="en-US"/>
-          </a:p>
-        </p:txBody>
-      </p:sp>
-    </p:spTree>
-    <p:extLst>
-      <p:ext uri="{BB962C8B-B14F-4D97-AF65-F5344CB8AC3E}">
-        <p14:creationId xmlns:p14="http://schemas.microsoft.com/office/powerpoint/2010/main" val="1024086991"/>
-      </p:ext>
-    </p:extLst>
-  </p:cSld>
-  <p:clrMapOvr>
-    <a:masterClrMapping/>
-  </p:clrMapOvr>
-</p:notes>
-</file>
-
-<file path=ppt/notesSlides/notesSlide7.xml><?xml version="1.0" encoding="utf-8"?>
-<p:notes xmlns:a="http://schemas.openxmlformats.org/drawingml/2006/main" xmlns:r="http://schemas.openxmlformats.org/officeDocument/2006/relationships" xmlns:p="http://schemas.openxmlformats.org/presentationml/2006/main">
-  <p:cSld>
-    <p:spTree>
-      <p:nvGrpSpPr>
-        <p:cNvPr id="1" name=""/>
-        <p:cNvGrpSpPr/>
-        <p:nvPr/>
-      </p:nvGrpSpPr>
-      <p:grpSpPr>
-        <a:xfrm>
-          <a:off x="0" y="0"/>
-          <a:ext cx="0" cy="0"/>
-          <a:chOff x="0" y="0"/>
-          <a:chExt cx="0" cy="0"/>
-        </a:xfrm>
-      </p:grpSpPr>
-      <p:sp>
-        <p:nvSpPr>
-          <p:cNvPr id="2" name="Slide Image Placeholder 1"/>
-          <p:cNvSpPr>
-            <a:spLocks noGrp="1" noRot="1" noChangeAspect="1"/>
-          </p:cNvSpPr>
-          <p:nvPr>
-            <p:ph type="sldImg"/>
-          </p:nvPr>
-        </p:nvSpPr>
-        <p:spPr/>
-      </p:sp>
-      <p:sp>
-        <p:nvSpPr>
-          <p:cNvPr id="3" name="Notes Placeholder 2"/>
-          <p:cNvSpPr>
-            <a:spLocks noGrp="1"/>
-          </p:cNvSpPr>
-          <p:nvPr>
-            <p:ph type="body" idx="1"/>
-          </p:nvPr>
-        </p:nvSpPr>
-        <p:spPr/>
-        <p:txBody>
-          <a:bodyPr/>
-          <a:lstStyle/>
-          <a:p>
-            <a:r>
-              <a:rPr lang="en-US" dirty="0"/>
-              <a:t/>
-            </a:r>
-            <a:endParaRPr lang="en-US" dirty="0"/>
-          </a:p>
-        </p:txBody>
-      </p:sp>
-      <p:sp>
-        <p:nvSpPr>
-          <p:cNvPr id="4" name="Slide Number Placeholder 3"/>
-          <p:cNvSpPr>
-            <a:spLocks noGrp="1"/>
-          </p:cNvSpPr>
-          <p:nvPr>
-            <p:ph type="sldNum" sz="quarter" idx="10"/>
-          </p:nvPr>
-        </p:nvSpPr>
-        <p:spPr/>
-        <p:txBody>
-          <a:bodyPr/>
-          <a:lstStyle/>
-          <a:p>
-            <a:fld id="{F7021451-1387-4CA6-816F-3879F97B5CBC}" type="slidenum">
-              <a:rPr lang="en-US"/>
-              <a:t>7</a:t>
             </a:fld>
             <a:endParaRPr lang="en-US"/>
           </a:p>
@@ -1853,7 +1764,7 @@
                   <a:srgbClr val="999999"/>
                 </a:solidFill>
               </a:rPr>
-              <a:t>Part 4: Analysis of Marketing Mix (7Ps) &amp; Recommendations</a:t>
+              <a:t>Part 4: Analysis of Marketing Mix (4Ps) &amp; Recommendations</a:t>
             </a:r>
             <a:endParaRPr lang="en-US" sz="900" dirty="0"/>
           </a:p>
@@ -1900,7 +1811,7 @@
                   <a:srgbClr val="999999"/>
                 </a:solidFill>
               </a:rPr>
-              <a:t>Executive Summary &amp; References</a:t>
+              <a:t>References</a:t>
             </a:r>
             <a:endParaRPr lang="en-US" sz="900" dirty="0"/>
           </a:p>
@@ -2130,8 +2041,8 @@
         </p:nvSpPr>
         <p:spPr>
           <a:xfrm>
-            <a:off x="594360" y="1627632"/>
-            <a:ext cx="3611880" cy="1325880"/>
+            <a:off x="594360" y="1600200"/>
+            <a:ext cx="3611880" cy="1371600"/>
           </a:xfrm>
           <a:prstGeom prst="rect">
             <a:avLst/>
@@ -2143,21 +2054,94 @@
           <a:bodyPr wrap="square" lIns="0" tIns="0" rIns="0" bIns="0" rtlCol="0" anchor="ctr"/>
           <a:lstStyle/>
           <a:p>
-            <a:pPr indent="0" marL="0">
-              <a:buNone/>
-            </a:pPr>
-            <a:r>
-              <a:rPr lang="en-US" sz="900" dirty="0">
-                <a:solidFill>
-                  <a:srgbClr val="666677"/>
+            <a:pPr marL="342900" indent="-342900">
+              <a:buSzPct val="100000"/>
+              <a:buChar char="•"/>
+            </a:pPr>
+            <a:r>
+              <a:rPr lang="en-US" sz="800" dirty="0">
+                <a:solidFill>
+                  <a:srgbClr val="999999"/>
                 </a:solidFill>
                 <a:latin typeface="Arial" pitchFamily="34" charset="0"/>
                 <a:ea typeface="Arial" pitchFamily="34" charset="-122"/>
                 <a:cs typeface="Arial" pitchFamily="34" charset="-120"/>
               </a:rPr>
-              <a:t>(content to be added)</a:t>
-            </a:r>
-            <a:endParaRPr lang="en-US" sz="900" dirty="0"/>
+              <a:t>2003 – Started with investment of $6.3 million by Elon Musk</a:t>
+            </a:r>
+            <a:endParaRPr lang="en-US" sz="800" dirty="0"/>
+          </a:p>
+          <a:p>
+            <a:pPr marL="342900" indent="-342900">
+              <a:buSzPct val="100000"/>
+              <a:buChar char="•"/>
+            </a:pPr>
+            <a:r>
+              <a:rPr lang="en-US" sz="800" dirty="0">
+                <a:solidFill>
+                  <a:srgbClr val="999999"/>
+                </a:solidFill>
+                <a:latin typeface="Arial" pitchFamily="34" charset="0"/>
+                <a:ea typeface="Arial" pitchFamily="34" charset="-122"/>
+                <a:cs typeface="Arial" pitchFamily="34" charset="-120"/>
+              </a:rPr>
+              <a:t>2008 – Tesla Roadster Launched (0-60mph in 3.7s, 395km range, lithium-ion battery)</a:t>
+            </a:r>
+            <a:endParaRPr lang="en-US" sz="800" dirty="0"/>
+          </a:p>
+          <a:p>
+            <a:pPr marL="342900" indent="-342900">
+              <a:buSzPct val="100000"/>
+              <a:buChar char="•"/>
+            </a:pPr>
+            <a:r>
+              <a:rPr lang="en-US" sz="800" dirty="0">
+                <a:solidFill>
+                  <a:srgbClr val="999999"/>
+                </a:solidFill>
+                <a:latin typeface="Arial" pitchFamily="34" charset="0"/>
+                <a:ea typeface="Arial" pitchFamily="34" charset="-122"/>
+                <a:cs typeface="Arial" pitchFamily="34" charset="-120"/>
+              </a:rPr>
+              <a:t>2012 – Model S, World's first premium electric sedan</a:t>
+            </a:r>
+            <a:endParaRPr lang="en-US" sz="800" dirty="0"/>
+          </a:p>
+          <a:p>
+            <a:pPr marL="342900" indent="-342900">
+              <a:buSzPct val="100000"/>
+              <a:buChar char="•"/>
+            </a:pPr>
+            <a:r>
+              <a:rPr lang="en-US" sz="800" dirty="0">
+                <a:solidFill>
+                  <a:srgbClr val="999999"/>
+                </a:solidFill>
+                <a:latin typeface="Arial" pitchFamily="34" charset="0"/>
+                <a:ea typeface="Arial" pitchFamily="34" charset="-122"/>
+                <a:cs typeface="Arial" pitchFamily="34" charset="-120"/>
+              </a:rPr>
+              <a:t>2015 – Model X released with Autopilot for Model S</a:t>
+            </a:r>
+            <a:endParaRPr lang="en-US" sz="800" dirty="0"/>
+          </a:p>
+          <a:p>
+            <a:pPr marL="342900" indent="-342900">
+              <a:buSzPct val="100000"/>
+              <a:buChar char="•"/>
+            </a:pPr>
+            <a:r>
+              <a:rPr lang="en-US" sz="800" dirty="0">
+                <a:solidFill>
+                  <a:srgbClr val="999999"/>
+                </a:solidFill>
+                <a:latin typeface="Arial" pitchFamily="34" charset="0"/>
+                <a:ea typeface="Arial" pitchFamily="34" charset="-122"/>
+                <a:cs typeface="Arial" pitchFamily="34" charset="-120"/>
+              </a:rPr>
+              <a:t>2017 – Model 3 released</a:t>
+            </a:r>
+            <a:endParaRPr lang="en-US" sz="800" dirty="0"/>
           </a:p>
         </p:txBody>
       </p:sp>
@@ -2255,8 +2239,8 @@
         </p:nvSpPr>
         <p:spPr>
           <a:xfrm>
-            <a:off x="4892040" y="1627632"/>
-            <a:ext cx="3611880" cy="1325880"/>
+            <a:off x="4892040" y="1600200"/>
+            <a:ext cx="3611880" cy="1371600"/>
           </a:xfrm>
           <a:prstGeom prst="rect">
             <a:avLst/>
@@ -2268,21 +2252,94 @@
           <a:bodyPr wrap="square" lIns="0" tIns="0" rIns="0" bIns="0" rtlCol="0" anchor="ctr"/>
           <a:lstStyle/>
           <a:p>
-            <a:pPr indent="0" marL="0">
-              <a:buNone/>
-            </a:pPr>
-            <a:r>
-              <a:rPr lang="en-US" sz="900" dirty="0">
-                <a:solidFill>
-                  <a:srgbClr val="666677"/>
+            <a:pPr marL="342900" indent="-342900">
+              <a:buSzPct val="100000"/>
+              <a:buChar char="•"/>
+            </a:pPr>
+            <a:r>
+              <a:rPr lang="en-US" sz="800" dirty="0">
+                <a:solidFill>
+                  <a:srgbClr val="999999"/>
                 </a:solidFill>
                 <a:latin typeface="Arial" pitchFamily="34" charset="0"/>
                 <a:ea typeface="Arial" pitchFamily="34" charset="-122"/>
                 <a:cs typeface="Arial" pitchFamily="34" charset="-120"/>
               </a:rPr>
-              <a:t>(content to be added)</a:t>
-            </a:r>
-            <a:endParaRPr lang="en-US" sz="900" dirty="0"/>
+              <a:t>Hinted in 2006 as an affordable car</a:t>
+            </a:r>
+            <a:endParaRPr lang="en-US" sz="800" dirty="0"/>
+          </a:p>
+          <a:p>
+            <a:pPr marL="342900" indent="-342900">
+              <a:buSzPct val="100000"/>
+              <a:buChar char="•"/>
+            </a:pPr>
+            <a:r>
+              <a:rPr lang="en-US" sz="800" dirty="0">
+                <a:solidFill>
+                  <a:srgbClr val="999999"/>
+                </a:solidFill>
+                <a:latin typeface="Arial" pitchFamily="34" charset="0"/>
+                <a:ea typeface="Arial" pitchFamily="34" charset="-122"/>
+                <a:cs typeface="Arial" pitchFamily="34" charset="-120"/>
+              </a:rPr>
+              <a:t>In 2008, announced to be a family car</a:t>
+            </a:r>
+            <a:endParaRPr lang="en-US" sz="800" dirty="0"/>
+          </a:p>
+          <a:p>
+            <a:pPr marL="342900" indent="-342900">
+              <a:buSzPct val="100000"/>
+              <a:buChar char="•"/>
+            </a:pPr>
+            <a:r>
+              <a:rPr lang="en-US" sz="800" dirty="0">
+                <a:solidFill>
+                  <a:srgbClr val="999999"/>
+                </a:solidFill>
+                <a:latin typeface="Arial" pitchFamily="34" charset="0"/>
+                <a:ea typeface="Arial" pitchFamily="34" charset="-122"/>
+                <a:cs typeface="Arial" pitchFamily="34" charset="-120"/>
+              </a:rPr>
+              <a:t>Unveiled in 2016, 325,000 reservation within a week</a:t>
+            </a:r>
+            <a:endParaRPr lang="en-US" sz="800" dirty="0"/>
+          </a:p>
+          <a:p>
+            <a:pPr marL="342900" indent="-342900">
+              <a:buSzPct val="100000"/>
+              <a:buChar char="•"/>
+            </a:pPr>
+            <a:r>
+              <a:rPr lang="en-US" sz="800" dirty="0">
+                <a:solidFill>
+                  <a:srgbClr val="999999"/>
+                </a:solidFill>
+                <a:latin typeface="Arial" pitchFamily="34" charset="0"/>
+                <a:ea typeface="Arial" pitchFamily="34" charset="-122"/>
+                <a:cs typeface="Arial" pitchFamily="34" charset="-120"/>
+              </a:rPr>
+              <a:t>By August 2017, 455,000 reservations made</a:t>
+            </a:r>
+            <a:endParaRPr lang="en-US" sz="800" dirty="0"/>
+          </a:p>
+          <a:p>
+            <a:pPr marL="342900" indent="-342900">
+              <a:buSzPct val="100000"/>
+              <a:buChar char="•"/>
+            </a:pPr>
+            <a:r>
+              <a:rPr lang="en-US" sz="800" dirty="0">
+                <a:solidFill>
+                  <a:srgbClr val="999999"/>
+                </a:solidFill>
+                <a:latin typeface="Arial" pitchFamily="34" charset="0"/>
+                <a:ea typeface="Arial" pitchFamily="34" charset="-122"/>
+                <a:cs typeface="Arial" pitchFamily="34" charset="-120"/>
+              </a:rPr>
+              <a:t>2020 Model 3 best selling EV worldwide</a:t>
+            </a:r>
+            <a:endParaRPr lang="en-US" sz="800" dirty="0"/>
           </a:p>
         </p:txBody>
       </p:sp>
@@ -2381,7 +2438,7 @@
         <p:spPr>
           <a:xfrm>
             <a:off x="658368" y="3566160"/>
-            <a:ext cx="7772400" cy="1234440"/>
+            <a:ext cx="7772400" cy="1280160"/>
           </a:xfrm>
           <a:prstGeom prst="rect">
             <a:avLst/>
@@ -2393,21 +2450,94 @@
           <a:bodyPr wrap="square" lIns="0" tIns="0" rIns="0" bIns="0" rtlCol="0" anchor="ctr"/>
           <a:lstStyle/>
           <a:p>
-            <a:pPr indent="0" marL="0">
-              <a:buNone/>
-            </a:pPr>
-            <a:r>
-              <a:rPr lang="en-US" sz="900" dirty="0">
-                <a:solidFill>
-                  <a:srgbClr val="666677"/>
+            <a:pPr marL="342900" indent="-342900">
+              <a:buSzPct val="100000"/>
+              <a:buChar char="•"/>
+            </a:pPr>
+            <a:r>
+              <a:rPr lang="en-US" sz="800" dirty="0">
+                <a:solidFill>
+                  <a:srgbClr val="999999"/>
                 </a:solidFill>
                 <a:latin typeface="Arial" pitchFamily="34" charset="0"/>
                 <a:ea typeface="Arial" pitchFamily="34" charset="-122"/>
                 <a:cs typeface="Arial" pitchFamily="34" charset="-120"/>
               </a:rPr>
-              <a:t>(content to be added)</a:t>
-            </a:r>
-            <a:endParaRPr lang="en-US" sz="900" dirty="0"/>
+              <a:t>Design and Technology – Elon believed in building a good product rather than spending on marketing. Let product do its own marketing.</a:t>
+            </a:r>
+            <a:endParaRPr lang="en-US" sz="800" dirty="0"/>
+          </a:p>
+          <a:p>
+            <a:pPr marL="342900" indent="-342900">
+              <a:buSzPct val="100000"/>
+              <a:buChar char="•"/>
+            </a:pPr>
+            <a:r>
+              <a:rPr lang="en-US" sz="800" dirty="0">
+                <a:solidFill>
+                  <a:srgbClr val="999999"/>
+                </a:solidFill>
+                <a:latin typeface="Arial" pitchFamily="34" charset="0"/>
+                <a:ea typeface="Arial" pitchFamily="34" charset="-122"/>
+                <a:cs typeface="Arial" pitchFamily="34" charset="-120"/>
+              </a:rPr>
+              <a:t>5 Star NCAP safety rating</a:t>
+            </a:r>
+            <a:endParaRPr lang="en-US" sz="800" dirty="0"/>
+          </a:p>
+          <a:p>
+            <a:pPr marL="342900" indent="-342900">
+              <a:buSzPct val="100000"/>
+              <a:buChar char="•"/>
+            </a:pPr>
+            <a:r>
+              <a:rPr lang="en-US" sz="800" dirty="0">
+                <a:solidFill>
+                  <a:srgbClr val="999999"/>
+                </a:solidFill>
+                <a:latin typeface="Arial" pitchFamily="34" charset="0"/>
+                <a:ea typeface="Arial" pitchFamily="34" charset="-122"/>
+                <a:cs typeface="Arial" pitchFamily="34" charset="-120"/>
+              </a:rPr>
+              <a:t>Priced above middle-income range but subsidy made it affordable for middle class.</a:t>
+            </a:r>
+            <a:endParaRPr lang="en-US" sz="800" dirty="0"/>
+          </a:p>
+          <a:p>
+            <a:pPr marL="342900" indent="-342900">
+              <a:buSzPct val="100000"/>
+              <a:buChar char="•"/>
+            </a:pPr>
+            <a:r>
+              <a:rPr lang="en-US" sz="800" dirty="0">
+                <a:solidFill>
+                  <a:srgbClr val="999999"/>
+                </a:solidFill>
+                <a:latin typeface="Arial" pitchFamily="34" charset="0"/>
+                <a:ea typeface="Arial" pitchFamily="34" charset="-122"/>
+                <a:cs typeface="Arial" pitchFamily="34" charset="-120"/>
+              </a:rPr>
+              <a:t>Elon Musk Branding [Brand Recognition, Brand Loyalty, Similar to Apple]</a:t>
+            </a:r>
+            <a:endParaRPr lang="en-US" sz="800" dirty="0"/>
+          </a:p>
+          <a:p>
+            <a:pPr marL="342900" indent="-342900">
+              <a:buSzPct val="100000"/>
+              <a:buChar char="•"/>
+            </a:pPr>
+            <a:r>
+              <a:rPr lang="en-US" sz="800" dirty="0">
+                <a:solidFill>
+                  <a:srgbClr val="999999"/>
+                </a:solidFill>
+                <a:latin typeface="Arial" pitchFamily="34" charset="0"/>
+                <a:ea typeface="Arial" pitchFamily="34" charset="-122"/>
+                <a:cs typeface="Arial" pitchFamily="34" charset="-120"/>
+              </a:rPr>
+              <a:t>Autopilot and Full Self Driving</a:t>
+            </a:r>
+            <a:endParaRPr lang="en-US" sz="800" dirty="0"/>
           </a:p>
         </p:txBody>
       </p:sp>
@@ -2635,8 +2765,8 @@
         </p:nvSpPr>
         <p:spPr>
           <a:xfrm>
-            <a:off x="594360" y="1600200"/>
-            <a:ext cx="3611880" cy="822960"/>
+            <a:off x="594360" y="1572768"/>
+            <a:ext cx="3611880" cy="777240"/>
           </a:xfrm>
           <a:prstGeom prst="rect">
             <a:avLst/>
@@ -2648,21 +2778,76 @@
           <a:bodyPr wrap="square" lIns="0" tIns="0" rIns="0" bIns="0" rtlCol="0" anchor="ctr"/>
           <a:lstStyle/>
           <a:p>
-            <a:pPr indent="0" marL="0">
-              <a:buNone/>
-            </a:pPr>
-            <a:r>
-              <a:rPr lang="en-US" sz="900" dirty="0">
-                <a:solidFill>
-                  <a:srgbClr val="666677"/>
+            <a:pPr marL="342900" indent="-342900">
+              <a:buSzPct val="100000"/>
+              <a:buChar char="•"/>
+            </a:pPr>
+            <a:r>
+              <a:rPr lang="en-US" sz="800" dirty="0">
+                <a:solidFill>
+                  <a:srgbClr val="999999"/>
                 </a:solidFill>
                 <a:latin typeface="Arial" pitchFamily="34" charset="0"/>
                 <a:ea typeface="Arial" pitchFamily="34" charset="-122"/>
                 <a:cs typeface="Arial" pitchFamily="34" charset="-120"/>
               </a:rPr>
-              <a:t>(content to be added)</a:t>
-            </a:r>
-            <a:endParaRPr lang="en-US" sz="900" dirty="0"/>
+              <a:t>People being more environmental conscious</a:t>
+            </a:r>
+            <a:endParaRPr lang="en-US" sz="800" dirty="0"/>
+          </a:p>
+          <a:p>
+            <a:pPr marL="342900" indent="-342900">
+              <a:buSzPct val="100000"/>
+              <a:buChar char="•"/>
+            </a:pPr>
+            <a:r>
+              <a:rPr lang="en-US" sz="800" dirty="0">
+                <a:solidFill>
+                  <a:srgbClr val="999999"/>
+                </a:solidFill>
+                <a:latin typeface="Arial" pitchFamily="34" charset="0"/>
+                <a:ea typeface="Arial" pitchFamily="34" charset="-122"/>
+                <a:cs typeface="Arial" pitchFamily="34" charset="-120"/>
+              </a:rPr>
+              <a:t>Shift to green energy cars</a:t>
+            </a:r>
+            <a:endParaRPr lang="en-US" sz="800" dirty="0"/>
+          </a:p>
+          <a:p>
+            <a:pPr marL="342900" indent="-342900">
+              <a:buSzPct val="100000"/>
+              <a:buChar char="•"/>
+            </a:pPr>
+            <a:r>
+              <a:rPr lang="en-US" sz="800" dirty="0">
+                <a:solidFill>
+                  <a:srgbClr val="999999"/>
+                </a:solidFill>
+                <a:latin typeface="Arial" pitchFamily="34" charset="0"/>
+                <a:ea typeface="Arial" pitchFamily="34" charset="-122"/>
+                <a:cs typeface="Arial" pitchFamily="34" charset="-120"/>
+              </a:rPr>
+              <a:t>Cheaper maintenance and running costs</a:t>
+            </a:r>
+            <a:endParaRPr lang="en-US" sz="800" dirty="0"/>
+          </a:p>
+          <a:p>
+            <a:pPr marL="342900" indent="-342900">
+              <a:buSzPct val="100000"/>
+              <a:buChar char="•"/>
+            </a:pPr>
+            <a:r>
+              <a:rPr lang="en-US" sz="800" dirty="0">
+                <a:solidFill>
+                  <a:srgbClr val="999999"/>
+                </a:solidFill>
+                <a:latin typeface="Arial" pitchFamily="34" charset="0"/>
+                <a:ea typeface="Arial" pitchFamily="34" charset="-122"/>
+                <a:cs typeface="Arial" pitchFamily="34" charset="-120"/>
+              </a:rPr>
+              <a:t>Government subsidies</a:t>
+            </a:r>
+            <a:endParaRPr lang="en-US" sz="800" dirty="0"/>
           </a:p>
         </p:txBody>
       </p:sp>
@@ -2674,7 +2859,7 @@
         </p:nvSpPr>
         <p:spPr>
           <a:xfrm>
-            <a:off x="594360" y="2468880"/>
+            <a:off x="594360" y="2423160"/>
             <a:ext cx="2743200" cy="201168"/>
           </a:xfrm>
           <a:prstGeom prst="rect">
@@ -2720,8 +2905,8 @@
           </p:nvPr>
         </p:nvGraphicFramePr>
         <p:xfrm>
-          <a:off x="594360" y="2697480"/>
-          <a:ext cx="3611880" cy="2103120"/>
+          <a:off x="594360" y="2651760"/>
+          <a:ext cx="3611880" cy="2194560"/>
         </p:xfrm>
         <a:graphic>
           <a:graphicData uri="http://schemas.openxmlformats.org/drawingml/2006/table">
@@ -2938,7 +3123,7 @@
                   </a:tcPr>
                 </a:tc>
               </a:tr>
-              <a:tr h="301752">
+              <a:tr h="320040">
                 <a:tc>
                   <a:txBody>
                     <a:bodyPr/>
@@ -3016,15 +3201,15 @@
                         <a:buNone/>
                       </a:pPr>
                       <a:r>
-                        <a:rPr lang="en-US" sz="750" dirty="0">
+                        <a:rPr lang="en-US" sz="750" b="1" dirty="0">
                           <a:solidFill>
-                            <a:srgbClr val="FFB74D"/>
+                            <a:srgbClr val="FF5252"/>
                           </a:solidFill>
                           <a:latin typeface="Arial" pitchFamily="34" charset="0"/>
                           <a:ea typeface="Arial" pitchFamily="34" charset="-122"/>
                           <a:cs typeface="Arial" pitchFamily="34" charset="-120"/>
                         </a:rPr>
-                        <a:t>—</a:t>
+                        <a:t>High</a:t>
                       </a:r>
                       <a:endParaRPr lang="en-US" sz="750" dirty="0">
                         <a:latin typeface="Arial" charset="0"/>
@@ -3092,7 +3277,7 @@
                           <a:ea typeface="Arial" pitchFamily="34" charset="-122"/>
                           <a:cs typeface="Arial" pitchFamily="34" charset="-120"/>
                         </a:rPr>
-                        <a:t>(content to be added)</a:t>
+                        <a:t>Support from government since made in US and pure EV.</a:t>
                       </a:r>
                       <a:endParaRPr lang="en-US" sz="700" dirty="0">
                         <a:latin typeface="Arial" charset="0"/>
@@ -3144,7 +3329,7 @@
                   </a:tcPr>
                 </a:tc>
               </a:tr>
-              <a:tr h="301752">
+              <a:tr h="320040">
                 <a:tc>
                   <a:txBody>
                     <a:bodyPr/>
@@ -3222,7 +3407,7 @@
                         <a:buNone/>
                       </a:pPr>
                       <a:r>
-                        <a:rPr lang="en-US" sz="750" dirty="0">
+                        <a:rPr lang="en-US" sz="750" b="1" dirty="0">
                           <a:solidFill>
                             <a:srgbClr val="FFB74D"/>
                           </a:solidFill>
@@ -3230,7 +3415,7 @@
                           <a:ea typeface="Arial" pitchFamily="34" charset="-122"/>
                           <a:cs typeface="Arial" pitchFamily="34" charset="-120"/>
                         </a:rPr>
-                        <a:t>—</a:t>
+                        <a:t>Moderate</a:t>
                       </a:r>
                       <a:endParaRPr lang="en-US" sz="750" dirty="0">
                         <a:latin typeface="Arial" charset="0"/>
@@ -3298,7 +3483,7 @@
                           <a:ea typeface="Arial" pitchFamily="34" charset="-122"/>
                           <a:cs typeface="Arial" pitchFamily="34" charset="-120"/>
                         </a:rPr>
-                        <a:t>(content to be added)</a:t>
+                        <a:t>Made in USA and priced affordably</a:t>
                       </a:r>
                       <a:endParaRPr lang="en-US" sz="700" dirty="0">
                         <a:latin typeface="Arial" charset="0"/>
@@ -3350,7 +3535,7 @@
                   </a:tcPr>
                 </a:tc>
               </a:tr>
-              <a:tr h="301752">
+              <a:tr h="320040">
                 <a:tc>
                   <a:txBody>
                     <a:bodyPr/>
@@ -3428,15 +3613,15 @@
                         <a:buNone/>
                       </a:pPr>
                       <a:r>
-                        <a:rPr lang="en-US" sz="750" dirty="0">
+                        <a:rPr lang="en-US" sz="750" b="1" dirty="0">
                           <a:solidFill>
-                            <a:srgbClr val="FFB74D"/>
+                            <a:srgbClr val="FF5252"/>
                           </a:solidFill>
                           <a:latin typeface="Arial" pitchFamily="34" charset="0"/>
                           <a:ea typeface="Arial" pitchFamily="34" charset="-122"/>
                           <a:cs typeface="Arial" pitchFamily="34" charset="-120"/>
                         </a:rPr>
-                        <a:t>—</a:t>
+                        <a:t>High</a:t>
                       </a:r>
                       <a:endParaRPr lang="en-US" sz="750" dirty="0">
                         <a:latin typeface="Arial" charset="0"/>
@@ -3504,7 +3689,7 @@
                           <a:ea typeface="Arial" pitchFamily="34" charset="-122"/>
                           <a:cs typeface="Arial" pitchFamily="34" charset="-120"/>
                         </a:rPr>
-                        <a:t>(content to be added)</a:t>
+                        <a:t>Change in market from ICE to EV due to many benefits.</a:t>
                       </a:r>
                       <a:endParaRPr lang="en-US" sz="700" dirty="0">
                         <a:latin typeface="Arial" charset="0"/>
@@ -3556,7 +3741,7 @@
                   </a:tcPr>
                 </a:tc>
               </a:tr>
-              <a:tr h="301752">
+              <a:tr h="320040">
                 <a:tc>
                   <a:txBody>
                     <a:bodyPr/>
@@ -3634,15 +3819,15 @@
                         <a:buNone/>
                       </a:pPr>
                       <a:r>
-                        <a:rPr lang="en-US" sz="750" dirty="0">
+                        <a:rPr lang="en-US" sz="750" b="1" dirty="0">
                           <a:solidFill>
-                            <a:srgbClr val="FFB74D"/>
+                            <a:srgbClr val="FF5252"/>
                           </a:solidFill>
                           <a:latin typeface="Arial" pitchFamily="34" charset="0"/>
                           <a:ea typeface="Arial" pitchFamily="34" charset="-122"/>
                           <a:cs typeface="Arial" pitchFamily="34" charset="-120"/>
                         </a:rPr>
-                        <a:t>—</a:t>
+                        <a:t>High</a:t>
                       </a:r>
                       <a:endParaRPr lang="en-US" sz="750" dirty="0">
                         <a:latin typeface="Arial" charset="0"/>
@@ -3710,7 +3895,7 @@
                           <a:ea typeface="Arial" pitchFamily="34" charset="-122"/>
                           <a:cs typeface="Arial" pitchFamily="34" charset="-120"/>
                         </a:rPr>
-                        <a:t>(content to be added)</a:t>
+                        <a:t>Minimalist design, Innovative features, Regular software updates, digital display for all controls.</a:t>
                       </a:r>
                       <a:endParaRPr lang="en-US" sz="700" dirty="0">
                         <a:latin typeface="Arial" charset="0"/>
@@ -3762,7 +3947,7 @@
                   </a:tcPr>
                 </a:tc>
               </a:tr>
-              <a:tr h="301752">
+              <a:tr h="320040">
                 <a:tc>
                   <a:txBody>
                     <a:bodyPr/>
@@ -3840,15 +4025,15 @@
                         <a:buNone/>
                       </a:pPr>
                       <a:r>
-                        <a:rPr lang="en-US" sz="750" dirty="0">
+                        <a:rPr lang="en-US" sz="750" b="1" dirty="0">
                           <a:solidFill>
-                            <a:srgbClr val="FFB74D"/>
+                            <a:srgbClr val="FF5252"/>
                           </a:solidFill>
                           <a:latin typeface="Arial" pitchFamily="34" charset="0"/>
                           <a:ea typeface="Arial" pitchFamily="34" charset="-122"/>
                           <a:cs typeface="Arial" pitchFamily="34" charset="-120"/>
                         </a:rPr>
-                        <a:t>—</a:t>
+                        <a:t>High</a:t>
                       </a:r>
                       <a:endParaRPr lang="en-US" sz="750" dirty="0">
                         <a:latin typeface="Arial" charset="0"/>
@@ -3916,7 +4101,7 @@
                           <a:ea typeface="Arial" pitchFamily="34" charset="-122"/>
                           <a:cs typeface="Arial" pitchFamily="34" charset="-120"/>
                         </a:rPr>
-                        <a:t>(content to be added)</a:t>
+                        <a:t>Pure EV, hence uses renewable source of energy. No pollution from burning of fuels.</a:t>
                       </a:r>
                       <a:endParaRPr lang="en-US" sz="700" dirty="0">
                         <a:latin typeface="Arial" charset="0"/>
@@ -3968,7 +4153,7 @@
                   </a:tcPr>
                 </a:tc>
               </a:tr>
-              <a:tr h="301752">
+              <a:tr h="320040">
                 <a:tc>
                   <a:txBody>
                     <a:bodyPr/>
@@ -4046,7 +4231,7 @@
                         <a:buNone/>
                       </a:pPr>
                       <a:r>
-                        <a:rPr lang="en-US" sz="750" dirty="0">
+                        <a:rPr lang="en-US" sz="750" b="1" dirty="0">
                           <a:solidFill>
                             <a:srgbClr val="FFB74D"/>
                           </a:solidFill>
@@ -4054,7 +4239,7 @@
                           <a:ea typeface="Arial" pitchFamily="34" charset="-122"/>
                           <a:cs typeface="Arial" pitchFamily="34" charset="-120"/>
                         </a:rPr>
-                        <a:t>—</a:t>
+                        <a:t>Moderate</a:t>
                       </a:r>
                       <a:endParaRPr lang="en-US" sz="750" dirty="0">
                         <a:latin typeface="Arial" charset="0"/>
@@ -4122,7 +4307,7 @@
                           <a:ea typeface="Arial" pitchFamily="34" charset="-122"/>
                           <a:cs typeface="Arial" pitchFamily="34" charset="-120"/>
                         </a:rPr>
-                        <a:t>(content to be added)</a:t>
+                        <a:t>Issues due to FSD and cybersecurity</a:t>
                       </a:r>
                       <a:endParaRPr lang="en-US" sz="700" dirty="0">
                         <a:latin typeface="Arial" charset="0"/>
@@ -4583,7 +4768,7 @@
                           <a:ea typeface="Arial" pitchFamily="34" charset="-122"/>
                           <a:cs typeface="Arial" pitchFamily="34" charset="-120"/>
                         </a:rPr>
-                        <a:t>—</a:t>
+                        <a:t>Moderate</a:t>
                       </a:r>
                       <a:endParaRPr lang="en-US" sz="800" dirty="0">
                         <a:latin typeface="Arial" charset="0"/>
@@ -4651,7 +4836,7 @@
                           <a:ea typeface="Arial" pitchFamily="34" charset="-122"/>
                           <a:cs typeface="Arial" pitchFamily="34" charset="-120"/>
                         </a:rPr>
-                        <a:t>(content to be added)</a:t>
+                        <a:t>Most of the materials self manufactured</a:t>
                       </a:r>
                       <a:endParaRPr lang="en-US" sz="750" dirty="0">
                         <a:latin typeface="Arial" charset="0"/>
@@ -4789,7 +4974,7 @@
                           <a:ea typeface="Arial" pitchFamily="34" charset="-122"/>
                           <a:cs typeface="Arial" pitchFamily="34" charset="-120"/>
                         </a:rPr>
-                        <a:t>—</a:t>
+                        <a:t>Moderate</a:t>
                       </a:r>
                       <a:endParaRPr lang="en-US" sz="800" dirty="0">
                         <a:latin typeface="Arial" charset="0"/>
@@ -4857,7 +5042,7 @@
                           <a:ea typeface="Arial" pitchFamily="34" charset="-122"/>
                           <a:cs typeface="Arial" pitchFamily="34" charset="-120"/>
                         </a:rPr>
-                        <a:t>(content to be added)</a:t>
+                        <a:t>Have many options.</a:t>
                       </a:r>
                       <a:endParaRPr lang="en-US" sz="750" dirty="0">
                         <a:latin typeface="Arial" charset="0"/>
@@ -4995,7 +5180,7 @@
                           <a:ea typeface="Arial" pitchFamily="34" charset="-122"/>
                           <a:cs typeface="Arial" pitchFamily="34" charset="-120"/>
                         </a:rPr>
-                        <a:t>—</a:t>
+                        <a:t>Moderate</a:t>
                       </a:r>
                       <a:endParaRPr lang="en-US" sz="800" dirty="0">
                         <a:latin typeface="Arial" charset="0"/>
@@ -5063,7 +5248,7 @@
                           <a:ea typeface="Arial" pitchFamily="34" charset="-122"/>
                           <a:cs typeface="Arial" pitchFamily="34" charset="-120"/>
                         </a:rPr>
-                        <a:t>(content to be added)</a:t>
+                        <a:t>Difficult since requires high investment and innovative technology.</a:t>
                       </a:r>
                       <a:endParaRPr lang="en-US" sz="750" dirty="0">
                         <a:latin typeface="Arial" charset="0"/>
@@ -5195,13 +5380,13 @@
                       <a:r>
                         <a:rPr lang="en-US" sz="800" b="1" dirty="0">
                           <a:solidFill>
-                            <a:srgbClr val="FFB74D"/>
+                            <a:srgbClr val="66BB6A"/>
                           </a:solidFill>
                           <a:latin typeface="Arial" pitchFamily="34" charset="0"/>
                           <a:ea typeface="Arial" pitchFamily="34" charset="-122"/>
                           <a:cs typeface="Arial" pitchFamily="34" charset="-120"/>
                         </a:rPr>
-                        <a:t>—</a:t>
+                        <a:t>Low</a:t>
                       </a:r>
                       <a:endParaRPr lang="en-US" sz="800" dirty="0">
                         <a:latin typeface="Arial" charset="0"/>
@@ -5269,7 +5454,7 @@
                           <a:ea typeface="Arial" pitchFamily="34" charset="-122"/>
                           <a:cs typeface="Arial" pitchFamily="34" charset="-120"/>
                         </a:rPr>
-                        <a:t>(content to be added)</a:t>
+                        <a:t>Better tech and cost alternative to ICE and hybrid</a:t>
                       </a:r>
                       <a:endParaRPr lang="en-US" sz="750" dirty="0">
                         <a:latin typeface="Arial" charset="0"/>
@@ -5401,13 +5586,13 @@
                       <a:r>
                         <a:rPr lang="en-US" sz="800" b="1" dirty="0">
                           <a:solidFill>
-                            <a:srgbClr val="FFB74D"/>
+                            <a:srgbClr val="FF5252"/>
                           </a:solidFill>
                           <a:latin typeface="Arial" pitchFamily="34" charset="0"/>
                           <a:ea typeface="Arial" pitchFamily="34" charset="-122"/>
                           <a:cs typeface="Arial" pitchFamily="34" charset="-120"/>
                         </a:rPr>
-                        <a:t>—</a:t>
+                        <a:t>High</a:t>
                       </a:r>
                       <a:endParaRPr lang="en-US" sz="800" dirty="0">
                         <a:latin typeface="Arial" charset="0"/>
@@ -5475,7 +5660,7 @@
                           <a:ea typeface="Arial" pitchFamily="34" charset="-122"/>
                           <a:cs typeface="Arial" pitchFamily="34" charset="-120"/>
                         </a:rPr>
-                        <a:t>(content to be added)</a:t>
+                        <a:t>Competitive market, fast tech advancements</a:t>
                       </a:r>
                       <a:endParaRPr lang="en-US" sz="750" dirty="0">
                         <a:latin typeface="Arial" charset="0"/>
@@ -5709,7 +5894,24 @@
                 <a:ea typeface="Arial" pitchFamily="34" charset="-122"/>
                 <a:cs typeface="Arial" pitchFamily="34" charset="-120"/>
               </a:rPr>
-              <a:t>(content to be added)</a:t>
+              <a:t>Good Product</a:t>
+            </a:r>
+            <a:endParaRPr lang="en-US" sz="650" dirty="0"/>
+          </a:p>
+          <a:p>
+            <a:pPr indent="0" marL="0">
+              <a:buNone/>
+            </a:pPr>
+            <a:r>
+              <a:rPr lang="en-US" sz="650" dirty="0">
+                <a:solidFill>
+                  <a:srgbClr val="666677"/>
+                </a:solidFill>
+                <a:latin typeface="Arial" pitchFamily="34" charset="0"/>
+                <a:ea typeface="Arial" pitchFamily="34" charset="-122"/>
+                <a:cs typeface="Arial" pitchFamily="34" charset="-120"/>
+              </a:rPr>
+              <a:t>Brand Loyalty</a:t>
             </a:r>
             <a:endParaRPr lang="en-US" sz="650" dirty="0"/>
           </a:p>
@@ -5827,7 +6029,24 @@
                 <a:ea typeface="Arial" pitchFamily="34" charset="-122"/>
                 <a:cs typeface="Arial" pitchFamily="34" charset="-120"/>
               </a:rPr>
-              <a:t>(content to be added)</a:t>
+              <a:t>Production Delays</a:t>
+            </a:r>
+            <a:endParaRPr lang="en-US" sz="650" dirty="0"/>
+          </a:p>
+          <a:p>
+            <a:pPr indent="0" marL="0">
+              <a:buNone/>
+            </a:pPr>
+            <a:r>
+              <a:rPr lang="en-US" sz="650" dirty="0">
+                <a:solidFill>
+                  <a:srgbClr val="666677"/>
+                </a:solidFill>
+                <a:latin typeface="Arial" pitchFamily="34" charset="0"/>
+                <a:ea typeface="Arial" pitchFamily="34" charset="-122"/>
+                <a:cs typeface="Arial" pitchFamily="34" charset="-120"/>
+              </a:rPr>
+              <a:t>Quality Control Issues</a:t>
             </a:r>
             <a:endParaRPr lang="en-US" sz="650" dirty="0"/>
           </a:p>
@@ -5945,7 +6164,24 @@
                 <a:ea typeface="Arial" pitchFamily="34" charset="-122"/>
                 <a:cs typeface="Arial" pitchFamily="34" charset="-120"/>
               </a:rPr>
-              <a:t>(content to be added)</a:t>
+              <a:t>Robotaxi, FSD</a:t>
+            </a:r>
+            <a:endParaRPr lang="en-US" sz="650" dirty="0"/>
+          </a:p>
+          <a:p>
+            <a:pPr indent="0" marL="0">
+              <a:buNone/>
+            </a:pPr>
+            <a:r>
+              <a:rPr lang="en-US" sz="650" dirty="0">
+                <a:solidFill>
+                  <a:srgbClr val="666677"/>
+                </a:solidFill>
+                <a:latin typeface="Arial" pitchFamily="34" charset="0"/>
+                <a:ea typeface="Arial" pitchFamily="34" charset="-122"/>
+                <a:cs typeface="Arial" pitchFamily="34" charset="-120"/>
+              </a:rPr>
+              <a:t>Emerging Market</a:t>
             </a:r>
             <a:endParaRPr lang="en-US" sz="650" dirty="0"/>
           </a:p>
@@ -6063,7 +6299,24 @@
                 <a:ea typeface="Arial" pitchFamily="34" charset="-122"/>
                 <a:cs typeface="Arial" pitchFamily="34" charset="-120"/>
               </a:rPr>
-              <a:t>(content to be added)</a:t>
+              <a:t>Competitive Market</a:t>
+            </a:r>
+            <a:endParaRPr lang="en-US" sz="650" dirty="0"/>
+          </a:p>
+          <a:p>
+            <a:pPr indent="0" marL="0">
+              <a:buNone/>
+            </a:pPr>
+            <a:r>
+              <a:rPr lang="en-US" sz="650" dirty="0">
+                <a:solidFill>
+                  <a:srgbClr val="666677"/>
+                </a:solidFill>
+                <a:latin typeface="Arial" pitchFamily="34" charset="0"/>
+                <a:ea typeface="Arial" pitchFamily="34" charset="-122"/>
+                <a:cs typeface="Arial" pitchFamily="34" charset="-120"/>
+              </a:rPr>
+              <a:t>Cybersecurity and FSD liability risk</a:t>
             </a:r>
             <a:endParaRPr lang="en-US" sz="650" dirty="0"/>
           </a:p>
@@ -6306,21 +6559,40 @@
           <a:bodyPr wrap="square" lIns="0" tIns="0" rIns="0" bIns="0" rtlCol="0" anchor="ctr"/>
           <a:lstStyle/>
           <a:p>
-            <a:pPr indent="0" marL="0">
-              <a:buNone/>
-            </a:pPr>
-            <a:r>
-              <a:rPr lang="en-US" sz="900" dirty="0">
-                <a:solidFill>
-                  <a:srgbClr val="666677"/>
+            <a:pPr marL="342900" indent="-342900">
+              <a:buSzPct val="100000"/>
+              <a:buChar char="•"/>
+            </a:pPr>
+            <a:r>
+              <a:rPr lang="en-US" sz="800" dirty="0">
+                <a:solidFill>
+                  <a:srgbClr val="999999"/>
                 </a:solidFill>
                 <a:latin typeface="Arial" pitchFamily="34" charset="0"/>
                 <a:ea typeface="Arial" pitchFamily="34" charset="-122"/>
                 <a:cs typeface="Arial" pitchFamily="34" charset="-120"/>
               </a:rPr>
-              <a:t>(content to be added)</a:t>
-            </a:r>
-            <a:endParaRPr lang="en-US" sz="900" dirty="0"/>
+              <a:t>Mostly Male buyers than female</a:t>
+            </a:r>
+            <a:endParaRPr lang="en-US" sz="800" dirty="0"/>
+          </a:p>
+          <a:p>
+            <a:pPr marL="342900" indent="-342900">
+              <a:buSzPct val="100000"/>
+              <a:buChar char="•"/>
+            </a:pPr>
+            <a:r>
+              <a:rPr lang="en-US" sz="800" dirty="0">
+                <a:solidFill>
+                  <a:srgbClr val="999999"/>
+                </a:solidFill>
+                <a:latin typeface="Arial" pitchFamily="34" charset="0"/>
+                <a:ea typeface="Arial" pitchFamily="34" charset="-122"/>
+                <a:cs typeface="Arial" pitchFamily="34" charset="-120"/>
+              </a:rPr>
+              <a:t>30-40 are major buyers</a:t>
+            </a:r>
+            <a:endParaRPr lang="en-US" sz="800" dirty="0"/>
           </a:p>
         </p:txBody>
       </p:sp>
@@ -6431,21 +6703,40 @@
           <a:bodyPr wrap="square" lIns="0" tIns="0" rIns="0" bIns="0" rtlCol="0" anchor="ctr"/>
           <a:lstStyle/>
           <a:p>
-            <a:pPr indent="0" marL="0">
-              <a:buNone/>
-            </a:pPr>
-            <a:r>
-              <a:rPr lang="en-US" sz="900" dirty="0">
-                <a:solidFill>
-                  <a:srgbClr val="666677"/>
+            <a:pPr marL="342900" indent="-342900">
+              <a:buSzPct val="100000"/>
+              <a:buChar char="•"/>
+            </a:pPr>
+            <a:r>
+              <a:rPr lang="en-US" sz="800" dirty="0">
+                <a:solidFill>
+                  <a:srgbClr val="999999"/>
                 </a:solidFill>
                 <a:latin typeface="Arial" pitchFamily="34" charset="0"/>
                 <a:ea typeface="Arial" pitchFamily="34" charset="-122"/>
                 <a:cs typeface="Arial" pitchFamily="34" charset="-120"/>
               </a:rPr>
-              <a:t>(content to be added)</a:t>
-            </a:r>
-            <a:endParaRPr lang="en-US" sz="900" dirty="0"/>
+              <a:t>High brand recognition</a:t>
+            </a:r>
+            <a:endParaRPr lang="en-US" sz="800" dirty="0"/>
+          </a:p>
+          <a:p>
+            <a:pPr marL="342900" indent="-342900">
+              <a:buSzPct val="100000"/>
+              <a:buChar char="•"/>
+            </a:pPr>
+            <a:r>
+              <a:rPr lang="en-US" sz="800" dirty="0">
+                <a:solidFill>
+                  <a:srgbClr val="999999"/>
+                </a:solidFill>
+                <a:latin typeface="Arial" pitchFamily="34" charset="0"/>
+                <a:ea typeface="Arial" pitchFamily="34" charset="-122"/>
+                <a:cs typeface="Arial" pitchFamily="34" charset="-120"/>
+              </a:rPr>
+              <a:t>Brand loyalty</a:t>
+            </a:r>
+            <a:endParaRPr lang="en-US" sz="800" dirty="0"/>
           </a:p>
         </p:txBody>
       </p:sp>
@@ -6556,21 +6847,76 @@
           <a:bodyPr wrap="square" lIns="0" tIns="0" rIns="0" bIns="0" rtlCol="0" anchor="ctr"/>
           <a:lstStyle/>
           <a:p>
-            <a:pPr indent="0" marL="0">
-              <a:buNone/>
-            </a:pPr>
-            <a:r>
-              <a:rPr lang="en-US" sz="900" dirty="0">
-                <a:solidFill>
-                  <a:srgbClr val="666677"/>
+            <a:pPr marL="342900" indent="-342900">
+              <a:buSzPct val="100000"/>
+              <a:buChar char="•"/>
+            </a:pPr>
+            <a:r>
+              <a:rPr lang="en-US" sz="800" dirty="0">
+                <a:solidFill>
+                  <a:srgbClr val="999999"/>
                 </a:solidFill>
                 <a:latin typeface="Arial" pitchFamily="34" charset="0"/>
                 <a:ea typeface="Arial" pitchFamily="34" charset="-122"/>
                 <a:cs typeface="Arial" pitchFamily="34" charset="-120"/>
               </a:rPr>
-              <a:t>(content to be added)</a:t>
-            </a:r>
-            <a:endParaRPr lang="en-US" sz="900" dirty="0"/>
+              <a:t>Innovative ideas</a:t>
+            </a:r>
+            <a:endParaRPr lang="en-US" sz="800" dirty="0"/>
+          </a:p>
+          <a:p>
+            <a:pPr marL="342900" indent="-342900">
+              <a:buSzPct val="100000"/>
+              <a:buChar char="•"/>
+            </a:pPr>
+            <a:r>
+              <a:rPr lang="en-US" sz="800" dirty="0">
+                <a:solidFill>
+                  <a:srgbClr val="999999"/>
+                </a:solidFill>
+                <a:latin typeface="Arial" pitchFamily="34" charset="0"/>
+                <a:ea typeface="Arial" pitchFamily="34" charset="-122"/>
+                <a:cs typeface="Arial" pitchFamily="34" charset="-120"/>
+              </a:rPr>
+              <a:t>Touch Screen display [Netflix, Games]</a:t>
+            </a:r>
+            <a:endParaRPr lang="en-US" sz="800" dirty="0"/>
+          </a:p>
+          <a:p>
+            <a:pPr marL="342900" indent="-342900">
+              <a:buSzPct val="100000"/>
+              <a:buChar char="•"/>
+            </a:pPr>
+            <a:r>
+              <a:rPr lang="en-US" sz="800" dirty="0">
+                <a:solidFill>
+                  <a:srgbClr val="999999"/>
+                </a:solidFill>
+                <a:latin typeface="Arial" pitchFamily="34" charset="0"/>
+                <a:ea typeface="Arial" pitchFamily="34" charset="-122"/>
+                <a:cs typeface="Arial" pitchFamily="34" charset="-120"/>
+              </a:rPr>
+              <a:t>Connects to PS5</a:t>
+            </a:r>
+            <a:endParaRPr lang="en-US" sz="800" dirty="0"/>
+          </a:p>
+          <a:p>
+            <a:pPr marL="342900" indent="-342900">
+              <a:buSzPct val="100000"/>
+              <a:buChar char="•"/>
+            </a:pPr>
+            <a:r>
+              <a:rPr lang="en-US" sz="800" dirty="0">
+                <a:solidFill>
+                  <a:srgbClr val="999999"/>
+                </a:solidFill>
+                <a:latin typeface="Arial" pitchFamily="34" charset="0"/>
+                <a:ea typeface="Arial" pitchFamily="34" charset="-122"/>
+                <a:cs typeface="Arial" pitchFamily="34" charset="-120"/>
+              </a:rPr>
+              <a:t>Many new fun features</a:t>
+            </a:r>
+            <a:endParaRPr lang="en-US" sz="800" dirty="0"/>
           </a:p>
         </p:txBody>
       </p:sp>
@@ -6668,8 +7014,8 @@
         </p:nvSpPr>
         <p:spPr>
           <a:xfrm>
-            <a:off x="640080" y="3154680"/>
-            <a:ext cx="3566160" cy="731520"/>
+            <a:off x="640080" y="3182112"/>
+            <a:ext cx="3566160" cy="640080"/>
           </a:xfrm>
           <a:prstGeom prst="rect">
             <a:avLst/>
@@ -6681,21 +7027,22 @@
           <a:bodyPr wrap="square" lIns="0" tIns="0" rIns="0" bIns="0" rtlCol="0" anchor="ctr"/>
           <a:lstStyle/>
           <a:p>
-            <a:pPr indent="0" marL="0">
-              <a:buNone/>
-            </a:pPr>
-            <a:r>
-              <a:rPr lang="en-US" sz="900" dirty="0">
-                <a:solidFill>
-                  <a:srgbClr val="666677"/>
+            <a:pPr marL="342900" indent="-342900">
+              <a:buSzPct val="100000"/>
+              <a:buChar char="•"/>
+            </a:pPr>
+            <a:r>
+              <a:rPr lang="en-US" sz="800" dirty="0">
+                <a:solidFill>
+                  <a:srgbClr val="999999"/>
                 </a:solidFill>
                 <a:latin typeface="Arial" pitchFamily="34" charset="0"/>
                 <a:ea typeface="Arial" pitchFamily="34" charset="-122"/>
                 <a:cs typeface="Arial" pitchFamily="34" charset="-120"/>
               </a:rPr>
-              <a:t>(content to be added)</a:t>
-            </a:r>
-            <a:endParaRPr lang="en-US" sz="900" dirty="0"/>
+              <a:t>Young People in their 20s and 30s</a:t>
+            </a:r>
+            <a:endParaRPr lang="en-US" sz="800" dirty="0"/>
           </a:p>
         </p:txBody>
       </p:sp>
@@ -6793,8 +7140,8 @@
         </p:nvSpPr>
         <p:spPr>
           <a:xfrm>
-            <a:off x="4937760" y="3154680"/>
-            <a:ext cx="3566160" cy="731520"/>
+            <a:off x="4937760" y="3182112"/>
+            <a:ext cx="3566160" cy="640080"/>
           </a:xfrm>
           <a:prstGeom prst="rect">
             <a:avLst/>
@@ -6806,21 +7153,58 @@
           <a:bodyPr wrap="square" lIns="0" tIns="0" rIns="0" bIns="0" rtlCol="0" anchor="ctr"/>
           <a:lstStyle/>
           <a:p>
-            <a:pPr indent="0" marL="0">
-              <a:buNone/>
-            </a:pPr>
-            <a:r>
-              <a:rPr lang="en-US" sz="900" dirty="0">
-                <a:solidFill>
-                  <a:srgbClr val="666677"/>
+            <a:pPr marL="342900" indent="-342900">
+              <a:buSzPct val="100000"/>
+              <a:buChar char="•"/>
+            </a:pPr>
+            <a:r>
+              <a:rPr lang="en-US" sz="800" dirty="0">
+                <a:solidFill>
+                  <a:srgbClr val="999999"/>
                 </a:solidFill>
                 <a:latin typeface="Arial" pitchFamily="34" charset="0"/>
                 <a:ea typeface="Arial" pitchFamily="34" charset="-122"/>
                 <a:cs typeface="Arial" pitchFamily="34" charset="-120"/>
               </a:rPr>
-              <a:t>(content to be added)</a:t>
-            </a:r>
-            <a:endParaRPr lang="en-US" sz="900" dirty="0"/>
+              <a:t>Eco Friendly</a:t>
+            </a:r>
+            <a:endParaRPr lang="en-US" sz="800" dirty="0"/>
+          </a:p>
+          <a:p>
+            <a:pPr marL="342900" indent="-342900">
+              <a:buSzPct val="100000"/>
+              <a:buChar char="•"/>
+            </a:pPr>
+            <a:r>
+              <a:rPr lang="en-US" sz="800" dirty="0">
+                <a:solidFill>
+                  <a:srgbClr val="999999"/>
+                </a:solidFill>
+                <a:latin typeface="Arial" pitchFamily="34" charset="0"/>
+                <a:ea typeface="Arial" pitchFamily="34" charset="-122"/>
+                <a:cs typeface="Arial" pitchFamily="34" charset="-120"/>
+              </a:rPr>
+              <a:t>Tech Savvy</a:t>
+            </a:r>
+            <a:endParaRPr lang="en-US" sz="800" dirty="0"/>
+          </a:p>
+          <a:p>
+            <a:pPr marL="342900" indent="-342900">
+              <a:buSzPct val="100000"/>
+              <a:buChar char="•"/>
+            </a:pPr>
+            <a:r>
+              <a:rPr lang="en-US" sz="800" dirty="0">
+                <a:solidFill>
+                  <a:srgbClr val="999999"/>
+                </a:solidFill>
+                <a:latin typeface="Arial" pitchFamily="34" charset="0"/>
+                <a:ea typeface="Arial" pitchFamily="34" charset="-122"/>
+                <a:cs typeface="Arial" pitchFamily="34" charset="-120"/>
+              </a:rPr>
+              <a:t>Entry Level Buyer for Electric Luxury Car</a:t>
+            </a:r>
+            <a:endParaRPr lang="en-US" sz="800" dirty="0"/>
           </a:p>
         </p:txBody>
       </p:sp>
@@ -6931,21 +7315,22 @@
           <a:bodyPr wrap="square" lIns="0" tIns="0" rIns="0" bIns="0" rtlCol="0" anchor="ctr"/>
           <a:lstStyle/>
           <a:p>
-            <a:pPr indent="0" marL="0">
-              <a:buNone/>
-            </a:pPr>
-            <a:r>
-              <a:rPr lang="en-US" sz="900" dirty="0">
-                <a:solidFill>
-                  <a:srgbClr val="666677"/>
+            <a:pPr marL="342900" indent="-342900">
+              <a:buSzPct val="100000"/>
+              <a:buChar char="•"/>
+            </a:pPr>
+            <a:r>
+              <a:rPr lang="en-US" sz="800" dirty="0">
+                <a:solidFill>
+                  <a:srgbClr val="999999"/>
                 </a:solidFill>
                 <a:latin typeface="Arial" pitchFamily="34" charset="0"/>
                 <a:ea typeface="Arial" pitchFamily="34" charset="-122"/>
                 <a:cs typeface="Arial" pitchFamily="34" charset="-120"/>
               </a:rPr>
-              <a:t>(content to be added)</a:t>
-            </a:r>
-            <a:endParaRPr lang="en-US" sz="900" dirty="0"/>
+              <a:t>Ultra high End &gt; High End &gt; SUV &gt; Mid Level [Priced at $35,000]</a:t>
+            </a:r>
+            <a:endParaRPr lang="en-US" sz="800" dirty="0"/>
           </a:p>
         </p:txBody>
       </p:sp>
@@ -7056,21 +7441,40 @@
           <a:bodyPr wrap="square" lIns="0" tIns="0" rIns="0" bIns="0" rtlCol="0" anchor="ctr"/>
           <a:lstStyle/>
           <a:p>
-            <a:pPr indent="0" marL="0">
-              <a:buNone/>
-            </a:pPr>
-            <a:r>
-              <a:rPr lang="en-US" sz="900" dirty="0">
-                <a:solidFill>
-                  <a:srgbClr val="666677"/>
+            <a:pPr marL="342900" indent="-342900">
+              <a:buSzPct val="100000"/>
+              <a:buChar char="•"/>
+            </a:pPr>
+            <a:r>
+              <a:rPr lang="en-US" sz="800" dirty="0">
+                <a:solidFill>
+                  <a:srgbClr val="999999"/>
                 </a:solidFill>
                 <a:latin typeface="Arial" pitchFamily="34" charset="0"/>
                 <a:ea typeface="Arial" pitchFamily="34" charset="-122"/>
                 <a:cs typeface="Arial" pitchFamily="34" charset="-120"/>
               </a:rPr>
-              <a:t>(content to be added)</a:t>
-            </a:r>
-            <a:endParaRPr lang="en-US" sz="900" dirty="0"/>
+              <a:t>Target Women</a:t>
+            </a:r>
+            <a:endParaRPr lang="en-US" sz="800" dirty="0"/>
+          </a:p>
+          <a:p>
+            <a:pPr marL="342900" indent="-342900">
+              <a:buSzPct val="100000"/>
+              <a:buChar char="•"/>
+            </a:pPr>
+            <a:r>
+              <a:rPr lang="en-US" sz="800" dirty="0">
+                <a:solidFill>
+                  <a:srgbClr val="999999"/>
+                </a:solidFill>
+                <a:latin typeface="Arial" pitchFamily="34" charset="0"/>
+                <a:ea typeface="Arial" pitchFamily="34" charset="-122"/>
+                <a:cs typeface="Arial" pitchFamily="34" charset="-120"/>
+              </a:rPr>
+              <a:t>More affordable car options for lower income market</a:t>
+            </a:r>
+            <a:endParaRPr lang="en-US" sz="800" dirty="0"/>
           </a:p>
         </p:txBody>
       </p:sp>
@@ -7198,7 +7602,7 @@
                 <a:ea typeface="Arial Black" pitchFamily="34" charset="-122"/>
                 <a:cs typeface="Arial Black" pitchFamily="34" charset="-120"/>
               </a:rPr>
-              <a:t>Marketing Mix — 7Ps &amp; Recommendations</a:t>
+              <a:t>Marketing Mix — 4Ps &amp; Recommendations</a:t>
             </a:r>
             <a:endParaRPr lang="en-US" sz="2200" dirty="0"/>
           </a:p>
@@ -7213,7 +7617,7 @@
         <p:spPr>
           <a:xfrm>
             <a:off x="457200" y="1188720"/>
-            <a:ext cx="1938528" cy="1691640"/>
+            <a:ext cx="3931920" cy="1600200"/>
           </a:xfrm>
           <a:prstGeom prst="rect">
             <a:avLst/>
@@ -7240,7 +7644,7 @@
         <p:spPr>
           <a:xfrm>
             <a:off x="457200" y="1188720"/>
-            <a:ext cx="1938528" cy="32004"/>
+            <a:ext cx="3931920" cy="32004"/>
           </a:xfrm>
           <a:prstGeom prst="rect">
             <a:avLst/>
@@ -7259,8 +7663,8 @@
         </p:nvSpPr>
         <p:spPr>
           <a:xfrm>
-            <a:off x="548640" y="1252728"/>
-            <a:ext cx="1737360" cy="182880"/>
+            <a:off x="594360" y="1261872"/>
+            <a:ext cx="3200400" cy="201168"/>
           </a:xfrm>
           <a:prstGeom prst="rect">
             <a:avLst/>
@@ -7276,7 +7680,7 @@
               <a:buNone/>
             </a:pPr>
             <a:r>
-              <a:rPr lang="en-US" sz="850" b="1" dirty="0">
+              <a:rPr lang="en-US" sz="1000" b="1" dirty="0">
                 <a:solidFill>
                   <a:srgbClr val="E82127"/>
                 </a:solidFill>
@@ -7286,7 +7690,7 @@
               </a:rPr>
               <a:t>4.1 Product</a:t>
             </a:r>
-            <a:endParaRPr lang="en-US" sz="850" dirty="0"/>
+            <a:endParaRPr lang="en-US" sz="1000" dirty="0"/>
           </a:p>
         </p:txBody>
       </p:sp>
@@ -7298,8 +7702,8 @@
         </p:nvSpPr>
         <p:spPr>
           <a:xfrm>
-            <a:off x="548640" y="1463040"/>
-            <a:ext cx="1737360" cy="1325880"/>
+            <a:off x="594360" y="1508760"/>
+            <a:ext cx="3657600" cy="1188720"/>
           </a:xfrm>
           <a:prstGeom prst="rect">
             <a:avLst/>
@@ -7311,21 +7715,76 @@
           <a:bodyPr wrap="square" lIns="0" tIns="0" rIns="0" bIns="0" rtlCol="0" anchor="ctr"/>
           <a:lstStyle/>
           <a:p>
-            <a:pPr indent="0" marL="0">
-              <a:buNone/>
-            </a:pPr>
-            <a:r>
-              <a:rPr lang="en-US" sz="900" dirty="0">
-                <a:solidFill>
-                  <a:srgbClr val="666677"/>
+            <a:pPr marL="342900" indent="-342900">
+              <a:buSzPct val="100000"/>
+              <a:buChar char="•"/>
+            </a:pPr>
+            <a:r>
+              <a:rPr lang="en-US" sz="850" dirty="0">
+                <a:solidFill>
+                  <a:srgbClr val="999999"/>
                 </a:solidFill>
                 <a:latin typeface="Arial" pitchFamily="34" charset="0"/>
                 <a:ea typeface="Arial" pitchFamily="34" charset="-122"/>
                 <a:cs typeface="Arial" pitchFamily="34" charset="-120"/>
               </a:rPr>
-              <a:t>(content to be added)</a:t>
-            </a:r>
-            <a:endParaRPr lang="en-US" sz="900" dirty="0"/>
+              <a:t>Great EV product</a:t>
+            </a:r>
+            <a:endParaRPr lang="en-US" sz="850" dirty="0"/>
+          </a:p>
+          <a:p>
+            <a:pPr marL="342900" indent="-342900">
+              <a:buSzPct val="100000"/>
+              <a:buChar char="•"/>
+            </a:pPr>
+            <a:r>
+              <a:rPr lang="en-US" sz="850" dirty="0">
+                <a:solidFill>
+                  <a:srgbClr val="999999"/>
+                </a:solidFill>
+                <a:latin typeface="Arial" pitchFamily="34" charset="0"/>
+                <a:ea typeface="Arial" pitchFamily="34" charset="-122"/>
+                <a:cs typeface="Arial" pitchFamily="34" charset="-120"/>
+              </a:rPr>
+              <a:t>Pure Electric</a:t>
+            </a:r>
+            <a:endParaRPr lang="en-US" sz="850" dirty="0"/>
+          </a:p>
+          <a:p>
+            <a:pPr marL="342900" indent="-342900">
+              <a:buSzPct val="100000"/>
+              <a:buChar char="•"/>
+            </a:pPr>
+            <a:r>
+              <a:rPr lang="en-US" sz="850" dirty="0">
+                <a:solidFill>
+                  <a:srgbClr val="999999"/>
+                </a:solidFill>
+                <a:latin typeface="Arial" pitchFamily="34" charset="0"/>
+                <a:ea typeface="Arial" pitchFamily="34" charset="-122"/>
+                <a:cs typeface="Arial" pitchFamily="34" charset="-120"/>
+              </a:rPr>
+              <a:t>Simple Structure</a:t>
+            </a:r>
+            <a:endParaRPr lang="en-US" sz="850" dirty="0"/>
+          </a:p>
+          <a:p>
+            <a:pPr marL="342900" indent="-342900">
+              <a:buSzPct val="100000"/>
+              <a:buChar char="•"/>
+            </a:pPr>
+            <a:r>
+              <a:rPr lang="en-US" sz="850" dirty="0">
+                <a:solidFill>
+                  <a:srgbClr val="999999"/>
+                </a:solidFill>
+                <a:latin typeface="Arial" pitchFamily="34" charset="0"/>
+                <a:ea typeface="Arial" pitchFamily="34" charset="-122"/>
+                <a:cs typeface="Arial" pitchFamily="34" charset="-120"/>
+              </a:rPr>
+              <a:t>Minimalist Design</a:t>
+            </a:r>
+            <a:endParaRPr lang="en-US" sz="850" dirty="0"/>
           </a:p>
         </p:txBody>
       </p:sp>
@@ -7337,8 +7796,8 @@
         </p:nvSpPr>
         <p:spPr>
           <a:xfrm>
-            <a:off x="2578608" y="1188720"/>
-            <a:ext cx="1938528" cy="1691640"/>
+            <a:off x="4663440" y="1188720"/>
+            <a:ext cx="3931920" cy="1600200"/>
           </a:xfrm>
           <a:prstGeom prst="rect">
             <a:avLst/>
@@ -7364,8 +7823,8 @@
         </p:nvSpPr>
         <p:spPr>
           <a:xfrm>
-            <a:off x="2578608" y="1188720"/>
-            <a:ext cx="1938528" cy="32004"/>
+            <a:off x="4663440" y="1188720"/>
+            <a:ext cx="3931920" cy="32004"/>
           </a:xfrm>
           <a:prstGeom prst="rect">
             <a:avLst/>
@@ -7384,8 +7843,8 @@
         </p:nvSpPr>
         <p:spPr>
           <a:xfrm>
-            <a:off x="2670048" y="1252728"/>
-            <a:ext cx="1737360" cy="182880"/>
+            <a:off x="4800600" y="1261872"/>
+            <a:ext cx="3200400" cy="201168"/>
           </a:xfrm>
           <a:prstGeom prst="rect">
             <a:avLst/>
@@ -7401,7 +7860,7 @@
               <a:buNone/>
             </a:pPr>
             <a:r>
-              <a:rPr lang="en-US" sz="850" b="1" dirty="0">
+              <a:rPr lang="en-US" sz="1000" b="1" dirty="0">
                 <a:solidFill>
                   <a:srgbClr val="E82127"/>
                 </a:solidFill>
@@ -7411,7 +7870,7 @@
               </a:rPr>
               <a:t>4.2 Pricing</a:t>
             </a:r>
-            <a:endParaRPr lang="en-US" sz="850" dirty="0"/>
+            <a:endParaRPr lang="en-US" sz="1000" dirty="0"/>
           </a:p>
         </p:txBody>
       </p:sp>
@@ -7423,8 +7882,8 @@
         </p:nvSpPr>
         <p:spPr>
           <a:xfrm>
-            <a:off x="2670048" y="1463040"/>
-            <a:ext cx="1737360" cy="1325880"/>
+            <a:off x="4800600" y="1508760"/>
+            <a:ext cx="3657600" cy="1188720"/>
           </a:xfrm>
           <a:prstGeom prst="rect">
             <a:avLst/>
@@ -7436,21 +7895,58 @@
           <a:bodyPr wrap="square" lIns="0" tIns="0" rIns="0" bIns="0" rtlCol="0" anchor="ctr"/>
           <a:lstStyle/>
           <a:p>
-            <a:pPr indent="0" marL="0">
-              <a:buNone/>
-            </a:pPr>
-            <a:r>
-              <a:rPr lang="en-US" sz="900" dirty="0">
-                <a:solidFill>
-                  <a:srgbClr val="666677"/>
+            <a:pPr marL="342900" indent="-342900">
+              <a:buSzPct val="100000"/>
+              <a:buChar char="•"/>
+            </a:pPr>
+            <a:r>
+              <a:rPr lang="en-US" sz="850" dirty="0">
+                <a:solidFill>
+                  <a:srgbClr val="999999"/>
                 </a:solidFill>
                 <a:latin typeface="Arial" pitchFamily="34" charset="0"/>
                 <a:ea typeface="Arial" pitchFamily="34" charset="-122"/>
                 <a:cs typeface="Arial" pitchFamily="34" charset="-120"/>
               </a:rPr>
-              <a:t>(content to be added)</a:t>
-            </a:r>
-            <a:endParaRPr lang="en-US" sz="900" dirty="0"/>
+              <a:t>Priced Slightly higher than affordable range</a:t>
+            </a:r>
+            <a:endParaRPr lang="en-US" sz="850" dirty="0"/>
+          </a:p>
+          <a:p>
+            <a:pPr marL="342900" indent="-342900">
+              <a:buSzPct val="100000"/>
+              <a:buChar char="•"/>
+            </a:pPr>
+            <a:r>
+              <a:rPr lang="en-US" sz="850" dirty="0">
+                <a:solidFill>
+                  <a:srgbClr val="999999"/>
+                </a:solidFill>
+                <a:latin typeface="Arial" pitchFamily="34" charset="0"/>
+                <a:ea typeface="Arial" pitchFamily="34" charset="-122"/>
+                <a:cs typeface="Arial" pitchFamily="34" charset="-120"/>
+              </a:rPr>
+              <a:t>But due to subsidy</a:t>
+            </a:r>
+            <a:endParaRPr lang="en-US" sz="850" dirty="0"/>
+          </a:p>
+          <a:p>
+            <a:pPr marL="342900" indent="-342900">
+              <a:buSzPct val="100000"/>
+              <a:buChar char="•"/>
+            </a:pPr>
+            <a:r>
+              <a:rPr lang="en-US" sz="850" dirty="0">
+                <a:solidFill>
+                  <a:srgbClr val="999999"/>
+                </a:solidFill>
+                <a:latin typeface="Arial" pitchFamily="34" charset="0"/>
+                <a:ea typeface="Arial" pitchFamily="34" charset="-122"/>
+                <a:cs typeface="Arial" pitchFamily="34" charset="-120"/>
+              </a:rPr>
+              <a:t>Feels premium but affordable</a:t>
+            </a:r>
+            <a:endParaRPr lang="en-US" sz="850" dirty="0"/>
           </a:p>
         </p:txBody>
       </p:sp>
@@ -7462,8 +7958,8 @@
         </p:nvSpPr>
         <p:spPr>
           <a:xfrm>
-            <a:off x="4700016" y="1188720"/>
-            <a:ext cx="1938528" cy="1691640"/>
+            <a:off x="457200" y="2971800"/>
+            <a:ext cx="3931920" cy="1600200"/>
           </a:xfrm>
           <a:prstGeom prst="rect">
             <a:avLst/>
@@ -7489,8 +7985,8 @@
         </p:nvSpPr>
         <p:spPr>
           <a:xfrm>
-            <a:off x="4700016" y="1188720"/>
-            <a:ext cx="1938528" cy="32004"/>
+            <a:off x="457200" y="2971800"/>
+            <a:ext cx="3931920" cy="32004"/>
           </a:xfrm>
           <a:prstGeom prst="rect">
             <a:avLst/>
@@ -7509,8 +8005,8 @@
         </p:nvSpPr>
         <p:spPr>
           <a:xfrm>
-            <a:off x="4791456" y="1252728"/>
-            <a:ext cx="1737360" cy="182880"/>
+            <a:off x="594360" y="3044952"/>
+            <a:ext cx="3200400" cy="201168"/>
           </a:xfrm>
           <a:prstGeom prst="rect">
             <a:avLst/>
@@ -7526,7 +8022,7 @@
               <a:buNone/>
             </a:pPr>
             <a:r>
-              <a:rPr lang="en-US" sz="850" b="1" dirty="0">
+              <a:rPr lang="en-US" sz="1000" b="1" dirty="0">
                 <a:solidFill>
                   <a:srgbClr val="E82127"/>
                 </a:solidFill>
@@ -7534,9 +8030,9 @@
                 <a:ea typeface="Arial" pitchFamily="34" charset="-122"/>
                 <a:cs typeface="Arial" pitchFamily="34" charset="-120"/>
               </a:rPr>
-              <a:t>4.3 Distribution</a:t>
-            </a:r>
-            <a:endParaRPr lang="en-US" sz="850" dirty="0"/>
+              <a:t>4.3 Place</a:t>
+            </a:r>
+            <a:endParaRPr lang="en-US" sz="1000" dirty="0"/>
           </a:p>
         </p:txBody>
       </p:sp>
@@ -7548,8 +8044,8 @@
         </p:nvSpPr>
         <p:spPr>
           <a:xfrm>
-            <a:off x="4791456" y="1463040"/>
-            <a:ext cx="1737360" cy="1325880"/>
+            <a:off x="594360" y="3291840"/>
+            <a:ext cx="3657600" cy="1188720"/>
           </a:xfrm>
           <a:prstGeom prst="rect">
             <a:avLst/>
@@ -7561,21 +8057,58 @@
           <a:bodyPr wrap="square" lIns="0" tIns="0" rIns="0" bIns="0" rtlCol="0" anchor="ctr"/>
           <a:lstStyle/>
           <a:p>
-            <a:pPr indent="0" marL="0">
-              <a:buNone/>
-            </a:pPr>
-            <a:r>
-              <a:rPr lang="en-US" sz="900" dirty="0">
-                <a:solidFill>
-                  <a:srgbClr val="666677"/>
+            <a:pPr marL="342900" indent="-342900">
+              <a:buSzPct val="100000"/>
+              <a:buChar char="•"/>
+            </a:pPr>
+            <a:r>
+              <a:rPr lang="en-US" sz="850" dirty="0">
+                <a:solidFill>
+                  <a:srgbClr val="999999"/>
                 </a:solidFill>
                 <a:latin typeface="Arial" pitchFamily="34" charset="0"/>
                 <a:ea typeface="Arial" pitchFamily="34" charset="-122"/>
                 <a:cs typeface="Arial" pitchFamily="34" charset="-120"/>
               </a:rPr>
-              <a:t>(content to be added)</a:t>
-            </a:r>
-            <a:endParaRPr lang="en-US" sz="900" dirty="0"/>
+              <a:t>Online Shopping</a:t>
+            </a:r>
+            <a:endParaRPr lang="en-US" sz="850" dirty="0"/>
+          </a:p>
+          <a:p>
+            <a:pPr marL="342900" indent="-342900">
+              <a:buSzPct val="100000"/>
+              <a:buChar char="•"/>
+            </a:pPr>
+            <a:r>
+              <a:rPr lang="en-US" sz="850" dirty="0">
+                <a:solidFill>
+                  <a:srgbClr val="999999"/>
+                </a:solidFill>
+                <a:latin typeface="Arial" pitchFamily="34" charset="0"/>
+                <a:ea typeface="Arial" pitchFamily="34" charset="-122"/>
+                <a:cs typeface="Arial" pitchFamily="34" charset="-120"/>
+              </a:rPr>
+              <a:t>No External Dealerships</a:t>
+            </a:r>
+            <a:endParaRPr lang="en-US" sz="850" dirty="0"/>
+          </a:p>
+          <a:p>
+            <a:pPr marL="342900" indent="-342900">
+              <a:buSzPct val="100000"/>
+              <a:buChar char="•"/>
+            </a:pPr>
+            <a:r>
+              <a:rPr lang="en-US" sz="850" dirty="0">
+                <a:solidFill>
+                  <a:srgbClr val="999999"/>
+                </a:solidFill>
+                <a:latin typeface="Arial" pitchFamily="34" charset="0"/>
+                <a:ea typeface="Arial" pitchFamily="34" charset="-122"/>
+                <a:cs typeface="Arial" pitchFamily="34" charset="-120"/>
+              </a:rPr>
+              <a:t>All Stores owned and managed by Tesla</a:t>
+            </a:r>
+            <a:endParaRPr lang="en-US" sz="850" dirty="0"/>
           </a:p>
         </p:txBody>
       </p:sp>
@@ -7587,8 +8120,8 @@
         </p:nvSpPr>
         <p:spPr>
           <a:xfrm>
-            <a:off x="6821424" y="1188720"/>
-            <a:ext cx="1938528" cy="1691640"/>
+            <a:off x="4663440" y="2971800"/>
+            <a:ext cx="3931920" cy="1600200"/>
           </a:xfrm>
           <a:prstGeom prst="rect">
             <a:avLst/>
@@ -7614,8 +8147,8 @@
         </p:nvSpPr>
         <p:spPr>
           <a:xfrm>
-            <a:off x="6821424" y="1188720"/>
-            <a:ext cx="1938528" cy="32004"/>
+            <a:off x="4663440" y="2971800"/>
+            <a:ext cx="3931920" cy="32004"/>
           </a:xfrm>
           <a:prstGeom prst="rect">
             <a:avLst/>
@@ -7634,8 +8167,8 @@
         </p:nvSpPr>
         <p:spPr>
           <a:xfrm>
-            <a:off x="6912864" y="1252728"/>
-            <a:ext cx="1737360" cy="182880"/>
+            <a:off x="4800600" y="3044952"/>
+            <a:ext cx="3200400" cy="201168"/>
           </a:xfrm>
           <a:prstGeom prst="rect">
             <a:avLst/>
@@ -7651,7 +8184,7 @@
               <a:buNone/>
             </a:pPr>
             <a:r>
-              <a:rPr lang="en-US" sz="850" b="1" dirty="0">
+              <a:rPr lang="en-US" sz="1000" b="1" dirty="0">
                 <a:solidFill>
                   <a:srgbClr val="E82127"/>
                 </a:solidFill>
@@ -7661,7 +8194,7 @@
               </a:rPr>
               <a:t>4.4 Promotion</a:t>
             </a:r>
-            <a:endParaRPr lang="en-US" sz="850" dirty="0"/>
+            <a:endParaRPr lang="en-US" sz="1000" dirty="0"/>
           </a:p>
         </p:txBody>
       </p:sp>
@@ -7673,8 +8206,8 @@
         </p:nvSpPr>
         <p:spPr>
           <a:xfrm>
-            <a:off x="6912864" y="1463040"/>
-            <a:ext cx="1737360" cy="1325880"/>
+            <a:off x="4800600" y="3291840"/>
+            <a:ext cx="3657600" cy="1188720"/>
           </a:xfrm>
           <a:prstGeom prst="rect">
             <a:avLst/>
@@ -7686,21 +8219,76 @@
           <a:bodyPr wrap="square" lIns="0" tIns="0" rIns="0" bIns="0" rtlCol="0" anchor="ctr"/>
           <a:lstStyle/>
           <a:p>
-            <a:pPr indent="0" marL="0">
-              <a:buNone/>
-            </a:pPr>
-            <a:r>
-              <a:rPr lang="en-US" sz="900" dirty="0">
-                <a:solidFill>
-                  <a:srgbClr val="666677"/>
+            <a:pPr marL="342900" indent="-342900">
+              <a:buSzPct val="100000"/>
+              <a:buChar char="•"/>
+            </a:pPr>
+            <a:r>
+              <a:rPr lang="en-US" sz="850" dirty="0">
+                <a:solidFill>
+                  <a:srgbClr val="999999"/>
                 </a:solidFill>
                 <a:latin typeface="Arial" pitchFamily="34" charset="0"/>
                 <a:ea typeface="Arial" pitchFamily="34" charset="-122"/>
                 <a:cs typeface="Arial" pitchFamily="34" charset="-120"/>
               </a:rPr>
-              <a:t>(content to be added)</a:t>
-            </a:r>
-            <a:endParaRPr lang="en-US" sz="900" dirty="0"/>
+              <a:t>$0 ad spent</a:t>
+            </a:r>
+            <a:endParaRPr lang="en-US" sz="850" dirty="0"/>
+          </a:p>
+          <a:p>
+            <a:pPr marL="342900" indent="-342900">
+              <a:buSzPct val="100000"/>
+              <a:buChar char="•"/>
+            </a:pPr>
+            <a:r>
+              <a:rPr lang="en-US" sz="850" dirty="0">
+                <a:solidFill>
+                  <a:srgbClr val="999999"/>
+                </a:solidFill>
+                <a:latin typeface="Arial" pitchFamily="34" charset="0"/>
+                <a:ea typeface="Arial" pitchFamily="34" charset="-122"/>
+                <a:cs typeface="Arial" pitchFamily="34" charset="-120"/>
+              </a:rPr>
+              <a:t>Elon Musk (200m followers)</a:t>
+            </a:r>
+            <a:endParaRPr lang="en-US" sz="850" dirty="0"/>
+          </a:p>
+          <a:p>
+            <a:pPr marL="342900" indent="-342900">
+              <a:buSzPct val="100000"/>
+              <a:buChar char="•"/>
+            </a:pPr>
+            <a:r>
+              <a:rPr lang="en-US" sz="850" dirty="0">
+                <a:solidFill>
+                  <a:srgbClr val="999999"/>
+                </a:solidFill>
+                <a:latin typeface="Arial" pitchFamily="34" charset="0"/>
+                <a:ea typeface="Arial" pitchFamily="34" charset="-122"/>
+                <a:cs typeface="Arial" pitchFamily="34" charset="-120"/>
+              </a:rPr>
+              <a:t>Bring in $19B of ad value</a:t>
+            </a:r>
+            <a:endParaRPr lang="en-US" sz="850" dirty="0"/>
+          </a:p>
+          <a:p>
+            <a:pPr marL="342900" indent="-342900">
+              <a:buSzPct val="100000"/>
+              <a:buChar char="•"/>
+            </a:pPr>
+            <a:r>
+              <a:rPr lang="en-US" sz="850" dirty="0">
+                <a:solidFill>
+                  <a:srgbClr val="999999"/>
+                </a:solidFill>
+                <a:latin typeface="Arial" pitchFamily="34" charset="0"/>
+                <a:ea typeface="Arial" pitchFamily="34" charset="-122"/>
+                <a:cs typeface="Arial" pitchFamily="34" charset="-120"/>
+              </a:rPr>
+              <a:t>Referral programs</a:t>
+            </a:r>
+            <a:endParaRPr lang="en-US" sz="850" dirty="0"/>
           </a:p>
         </p:txBody>
       </p:sp>
@@ -7712,8 +8300,8 @@
         </p:nvSpPr>
         <p:spPr>
           <a:xfrm>
-            <a:off x="457200" y="3063240"/>
-            <a:ext cx="2606040" cy="1234440"/>
+            <a:off x="457200" y="4663440"/>
+            <a:ext cx="8229600" cy="365760"/>
           </a:xfrm>
           <a:prstGeom prst="rect">
             <a:avLst/>
@@ -7739,14 +8327,14 @@
         </p:nvSpPr>
         <p:spPr>
           <a:xfrm>
-            <a:off x="457200" y="3063240"/>
-            <a:ext cx="2606040" cy="32004"/>
+            <a:off x="457200" y="4663440"/>
+            <a:ext cx="45720" cy="365760"/>
           </a:xfrm>
           <a:prstGeom prst="rect">
             <a:avLst/>
           </a:prstGeom>
           <a:solidFill>
-            <a:srgbClr val="E82127"/>
+            <a:srgbClr val="E65100"/>
           </a:solidFill>
           <a:ln/>
         </p:spPr>
@@ -7759,8 +8347,8 @@
         </p:nvSpPr>
         <p:spPr>
           <a:xfrm>
-            <a:off x="548640" y="3127248"/>
-            <a:ext cx="2377440" cy="182880"/>
+            <a:off x="640080" y="4681728"/>
+            <a:ext cx="1645920" cy="164592"/>
           </a:xfrm>
           <a:prstGeom prst="rect">
             <a:avLst/>
@@ -7776,17 +8364,17 @@
               <a:buNone/>
             </a:pPr>
             <a:r>
-              <a:rPr lang="en-US" sz="850" b="1" dirty="0">
-                <a:solidFill>
-                  <a:srgbClr val="E82127"/>
+              <a:rPr lang="en-US" sz="800" b="1" dirty="0">
+                <a:solidFill>
+                  <a:srgbClr val="FF9800"/>
                 </a:solidFill>
                 <a:latin typeface="Arial" pitchFamily="34" charset="0"/>
                 <a:ea typeface="Arial" pitchFamily="34" charset="-122"/>
                 <a:cs typeface="Arial" pitchFamily="34" charset="-120"/>
               </a:rPr>
-              <a:t>4.5 People</a:t>
-            </a:r>
-            <a:endParaRPr lang="en-US" sz="850" dirty="0"/>
+              <a:t>4.5 Recommendations</a:t>
+            </a:r>
+            <a:endParaRPr lang="en-US" sz="800" dirty="0"/>
           </a:p>
         </p:txBody>
       </p:sp>
@@ -7798,8 +8386,8 @@
         </p:nvSpPr>
         <p:spPr>
           <a:xfrm>
-            <a:off x="548640" y="3337560"/>
-            <a:ext cx="2377440" cy="914400"/>
+            <a:off x="2377440" y="4681728"/>
+            <a:ext cx="6035040" cy="274320"/>
           </a:xfrm>
           <a:prstGeom prst="rect">
             <a:avLst/>
@@ -7815,7 +8403,7 @@
               <a:buNone/>
             </a:pPr>
             <a:r>
-              <a:rPr lang="en-US" sz="900" dirty="0">
+              <a:rPr lang="en-US" sz="800" dirty="0">
                 <a:solidFill>
                   <a:srgbClr val="666677"/>
                 </a:solidFill>
@@ -7823,384 +8411,9 @@
                 <a:ea typeface="Arial" pitchFamily="34" charset="-122"/>
                 <a:cs typeface="Arial" pitchFamily="34" charset="-120"/>
               </a:rPr>
-              <a:t>(content to be added)</a:t>
-            </a:r>
-            <a:endParaRPr lang="en-US" sz="900" dirty="0"/>
-          </a:p>
-        </p:txBody>
-      </p:sp>
-      <p:sp>
-        <p:nvSpPr>
-          <p:cNvPr id="25" name="Shape 23"/>
-          <p:cNvSpPr/>
-          <p:nvPr/>
-        </p:nvSpPr>
-        <p:spPr>
-          <a:xfrm>
-            <a:off x="3291840" y="3063240"/>
-            <a:ext cx="2606040" cy="1234440"/>
-          </a:xfrm>
-          <a:prstGeom prst="rect">
-            <a:avLst/>
-          </a:prstGeom>
-          <a:solidFill>
-            <a:srgbClr val="141420"/>
-          </a:solidFill>
-          <a:ln/>
-          <a:effectLst>
-            <a:outerShdw sx="100000" sy="100000" kx="0" ky="0" algn="bl" rotWithShape="0" blurRad="76200" dist="25400" dir="8100000">
-              <a:srgbClr val="000000">
-                <a:alpha val="35000"/>
-              </a:srgbClr>
-            </a:outerShdw>
-          </a:effectLst>
-        </p:spPr>
-      </p:sp>
-      <p:sp>
-        <p:nvSpPr>
-          <p:cNvPr id="26" name="Shape 24"/>
-          <p:cNvSpPr/>
-          <p:nvPr/>
-        </p:nvSpPr>
-        <p:spPr>
-          <a:xfrm>
-            <a:off x="3291840" y="3063240"/>
-            <a:ext cx="2606040" cy="32004"/>
-          </a:xfrm>
-          <a:prstGeom prst="rect">
-            <a:avLst/>
-          </a:prstGeom>
-          <a:solidFill>
-            <a:srgbClr val="E82127"/>
-          </a:solidFill>
-          <a:ln/>
-        </p:spPr>
-      </p:sp>
-      <p:sp>
-        <p:nvSpPr>
-          <p:cNvPr id="27" name="Text 25"/>
-          <p:cNvSpPr/>
-          <p:nvPr/>
-        </p:nvSpPr>
-        <p:spPr>
-          <a:xfrm>
-            <a:off x="3383280" y="3127248"/>
-            <a:ext cx="2377440" cy="182880"/>
-          </a:xfrm>
-          <a:prstGeom prst="rect">
-            <a:avLst/>
-          </a:prstGeom>
-          <a:noFill/>
-          <a:ln/>
-        </p:spPr>
-        <p:txBody>
-          <a:bodyPr wrap="square" lIns="0" tIns="0" rIns="0" bIns="0" rtlCol="0" anchor="ctr"/>
-          <a:lstStyle/>
-          <a:p>
-            <a:pPr indent="0" marL="0">
-              <a:buNone/>
-            </a:pPr>
-            <a:r>
-              <a:rPr lang="en-US" sz="850" b="1" dirty="0">
-                <a:solidFill>
-                  <a:srgbClr val="E82127"/>
-                </a:solidFill>
-                <a:latin typeface="Arial" pitchFamily="34" charset="0"/>
-                <a:ea typeface="Arial" pitchFamily="34" charset="-122"/>
-                <a:cs typeface="Arial" pitchFamily="34" charset="-120"/>
-              </a:rPr>
-              <a:t>4.6 Process</a:t>
-            </a:r>
-            <a:endParaRPr lang="en-US" sz="850" dirty="0"/>
-          </a:p>
-        </p:txBody>
-      </p:sp>
-      <p:sp>
-        <p:nvSpPr>
-          <p:cNvPr id="28" name="Text 26"/>
-          <p:cNvSpPr/>
-          <p:nvPr/>
-        </p:nvSpPr>
-        <p:spPr>
-          <a:xfrm>
-            <a:off x="3383280" y="3337560"/>
-            <a:ext cx="2377440" cy="914400"/>
-          </a:xfrm>
-          <a:prstGeom prst="rect">
-            <a:avLst/>
-          </a:prstGeom>
-          <a:noFill/>
-          <a:ln/>
-        </p:spPr>
-        <p:txBody>
-          <a:bodyPr wrap="square" lIns="0" tIns="0" rIns="0" bIns="0" rtlCol="0" anchor="ctr"/>
-          <a:lstStyle/>
-          <a:p>
-            <a:pPr indent="0" marL="0">
-              <a:buNone/>
-            </a:pPr>
-            <a:r>
-              <a:rPr lang="en-US" sz="900" dirty="0">
-                <a:solidFill>
-                  <a:srgbClr val="666677"/>
-                </a:solidFill>
-                <a:latin typeface="Arial" pitchFamily="34" charset="0"/>
-                <a:ea typeface="Arial" pitchFamily="34" charset="-122"/>
-                <a:cs typeface="Arial" pitchFamily="34" charset="-120"/>
-              </a:rPr>
-              <a:t>(content to be added)</a:t>
-            </a:r>
-            <a:endParaRPr lang="en-US" sz="900" dirty="0"/>
-          </a:p>
-        </p:txBody>
-      </p:sp>
-      <p:sp>
-        <p:nvSpPr>
-          <p:cNvPr id="29" name="Shape 27"/>
-          <p:cNvSpPr/>
-          <p:nvPr/>
-        </p:nvSpPr>
-        <p:spPr>
-          <a:xfrm>
-            <a:off x="6126480" y="3063240"/>
-            <a:ext cx="2606040" cy="1234440"/>
-          </a:xfrm>
-          <a:prstGeom prst="rect">
-            <a:avLst/>
-          </a:prstGeom>
-          <a:solidFill>
-            <a:srgbClr val="141420"/>
-          </a:solidFill>
-          <a:ln/>
-          <a:effectLst>
-            <a:outerShdw sx="100000" sy="100000" kx="0" ky="0" algn="bl" rotWithShape="0" blurRad="76200" dist="25400" dir="8100000">
-              <a:srgbClr val="000000">
-                <a:alpha val="35000"/>
-              </a:srgbClr>
-            </a:outerShdw>
-          </a:effectLst>
-        </p:spPr>
-      </p:sp>
-      <p:sp>
-        <p:nvSpPr>
-          <p:cNvPr id="30" name="Shape 28"/>
-          <p:cNvSpPr/>
-          <p:nvPr/>
-        </p:nvSpPr>
-        <p:spPr>
-          <a:xfrm>
-            <a:off x="6126480" y="3063240"/>
-            <a:ext cx="2606040" cy="32004"/>
-          </a:xfrm>
-          <a:prstGeom prst="rect">
-            <a:avLst/>
-          </a:prstGeom>
-          <a:solidFill>
-            <a:srgbClr val="E82127"/>
-          </a:solidFill>
-          <a:ln/>
-        </p:spPr>
-      </p:sp>
-      <p:sp>
-        <p:nvSpPr>
-          <p:cNvPr id="31" name="Text 29"/>
-          <p:cNvSpPr/>
-          <p:nvPr/>
-        </p:nvSpPr>
-        <p:spPr>
-          <a:xfrm>
-            <a:off x="6217920" y="3127248"/>
-            <a:ext cx="2377440" cy="182880"/>
-          </a:xfrm>
-          <a:prstGeom prst="rect">
-            <a:avLst/>
-          </a:prstGeom>
-          <a:noFill/>
-          <a:ln/>
-        </p:spPr>
-        <p:txBody>
-          <a:bodyPr wrap="square" lIns="0" tIns="0" rIns="0" bIns="0" rtlCol="0" anchor="ctr"/>
-          <a:lstStyle/>
-          <a:p>
-            <a:pPr indent="0" marL="0">
-              <a:buNone/>
-            </a:pPr>
-            <a:r>
-              <a:rPr lang="en-US" sz="850" b="1" dirty="0">
-                <a:solidFill>
-                  <a:srgbClr val="E82127"/>
-                </a:solidFill>
-                <a:latin typeface="Arial" pitchFamily="34" charset="0"/>
-                <a:ea typeface="Arial" pitchFamily="34" charset="-122"/>
-                <a:cs typeface="Arial" pitchFamily="34" charset="-120"/>
-              </a:rPr>
-              <a:t>4.7 Physical Evidence</a:t>
-            </a:r>
-            <a:endParaRPr lang="en-US" sz="850" dirty="0"/>
-          </a:p>
-        </p:txBody>
-      </p:sp>
-      <p:sp>
-        <p:nvSpPr>
-          <p:cNvPr id="32" name="Text 30"/>
-          <p:cNvSpPr/>
-          <p:nvPr/>
-        </p:nvSpPr>
-        <p:spPr>
-          <a:xfrm>
-            <a:off x="6217920" y="3337560"/>
-            <a:ext cx="2377440" cy="914400"/>
-          </a:xfrm>
-          <a:prstGeom prst="rect">
-            <a:avLst/>
-          </a:prstGeom>
-          <a:noFill/>
-          <a:ln/>
-        </p:spPr>
-        <p:txBody>
-          <a:bodyPr wrap="square" lIns="0" tIns="0" rIns="0" bIns="0" rtlCol="0" anchor="ctr"/>
-          <a:lstStyle/>
-          <a:p>
-            <a:pPr indent="0" marL="0">
-              <a:buNone/>
-            </a:pPr>
-            <a:r>
-              <a:rPr lang="en-US" sz="900" dirty="0">
-                <a:solidFill>
-                  <a:srgbClr val="666677"/>
-                </a:solidFill>
-                <a:latin typeface="Arial" pitchFamily="34" charset="0"/>
-                <a:ea typeface="Arial" pitchFamily="34" charset="-122"/>
-                <a:cs typeface="Arial" pitchFamily="34" charset="-120"/>
-              </a:rPr>
-              <a:t>(content to be added)</a:t>
-            </a:r>
-            <a:endParaRPr lang="en-US" sz="900" dirty="0"/>
-          </a:p>
-        </p:txBody>
-      </p:sp>
-      <p:sp>
-        <p:nvSpPr>
-          <p:cNvPr id="33" name="Shape 31"/>
-          <p:cNvSpPr/>
-          <p:nvPr/>
-        </p:nvSpPr>
-        <p:spPr>
-          <a:xfrm>
-            <a:off x="457200" y="4434840"/>
-            <a:ext cx="8229600" cy="548640"/>
-          </a:xfrm>
-          <a:prstGeom prst="rect">
-            <a:avLst/>
-          </a:prstGeom>
-          <a:solidFill>
-            <a:srgbClr val="141420"/>
-          </a:solidFill>
-          <a:ln/>
-          <a:effectLst>
-            <a:outerShdw sx="100000" sy="100000" kx="0" ky="0" algn="bl" rotWithShape="0" blurRad="76200" dist="25400" dir="8100000">
-              <a:srgbClr val="000000">
-                <a:alpha val="35000"/>
-              </a:srgbClr>
-            </a:outerShdw>
-          </a:effectLst>
-        </p:spPr>
-      </p:sp>
-      <p:sp>
-        <p:nvSpPr>
-          <p:cNvPr id="34" name="Shape 32"/>
-          <p:cNvSpPr/>
-          <p:nvPr/>
-        </p:nvSpPr>
-        <p:spPr>
-          <a:xfrm>
-            <a:off x="457200" y="4434840"/>
-            <a:ext cx="45720" cy="548640"/>
-          </a:xfrm>
-          <a:prstGeom prst="rect">
-            <a:avLst/>
-          </a:prstGeom>
-          <a:solidFill>
-            <a:srgbClr val="E65100"/>
-          </a:solidFill>
-          <a:ln/>
-        </p:spPr>
-      </p:sp>
-      <p:sp>
-        <p:nvSpPr>
-          <p:cNvPr id="35" name="Text 33"/>
-          <p:cNvSpPr/>
-          <p:nvPr/>
-        </p:nvSpPr>
-        <p:spPr>
-          <a:xfrm>
-            <a:off x="640080" y="4462272"/>
-            <a:ext cx="1828800" cy="182880"/>
-          </a:xfrm>
-          <a:prstGeom prst="rect">
-            <a:avLst/>
-          </a:prstGeom>
-          <a:noFill/>
-          <a:ln/>
-        </p:spPr>
-        <p:txBody>
-          <a:bodyPr wrap="square" lIns="0" tIns="0" rIns="0" bIns="0" rtlCol="0" anchor="ctr"/>
-          <a:lstStyle/>
-          <a:p>
-            <a:pPr indent="0" marL="0">
-              <a:buNone/>
-            </a:pPr>
-            <a:r>
-              <a:rPr lang="en-US" sz="800" b="1" dirty="0">
-                <a:solidFill>
-                  <a:srgbClr val="FF9800"/>
-                </a:solidFill>
-                <a:latin typeface="Arial" pitchFamily="34" charset="0"/>
-                <a:ea typeface="Arial" pitchFamily="34" charset="-122"/>
-                <a:cs typeface="Arial" pitchFamily="34" charset="-120"/>
-              </a:rPr>
-              <a:t>4.8 Recommendations</a:t>
+              <a:t>Spend more on digital ads, more product options, more customizations options</a:t>
             </a:r>
             <a:endParaRPr lang="en-US" sz="800" dirty="0"/>
-          </a:p>
-        </p:txBody>
-      </p:sp>
-      <p:sp>
-        <p:nvSpPr>
-          <p:cNvPr id="36" name="Text 34"/>
-          <p:cNvSpPr/>
-          <p:nvPr/>
-        </p:nvSpPr>
-        <p:spPr>
-          <a:xfrm>
-            <a:off x="640080" y="4645152"/>
-            <a:ext cx="7863840" cy="274320"/>
-          </a:xfrm>
-          <a:prstGeom prst="rect">
-            <a:avLst/>
-          </a:prstGeom>
-          <a:noFill/>
-          <a:ln/>
-        </p:spPr>
-        <p:txBody>
-          <a:bodyPr wrap="square" lIns="0" tIns="0" rIns="0" bIns="0" rtlCol="0" anchor="ctr"/>
-          <a:lstStyle/>
-          <a:p>
-            <a:pPr indent="0" marL="0">
-              <a:buNone/>
-            </a:pPr>
-            <a:r>
-              <a:rPr lang="en-US" sz="900" dirty="0">
-                <a:solidFill>
-                  <a:srgbClr val="666677"/>
-                </a:solidFill>
-                <a:latin typeface="Arial" pitchFamily="34" charset="0"/>
-                <a:ea typeface="Arial" pitchFamily="34" charset="-122"/>
-                <a:cs typeface="Arial" pitchFamily="34" charset="-120"/>
-              </a:rPr>
-              <a:t>(content to be added)</a:t>
-            </a:r>
-            <a:endParaRPr lang="en-US" sz="900" dirty="0"/>
           </a:p>
         </p:txBody>
       </p:sp>
@@ -8258,7 +8471,27 @@
       </p:sp>
       <p:sp>
         <p:nvSpPr>
-          <p:cNvPr id="3" name="Text 1"/>
+          <p:cNvPr id="3" name="Shape 1"/>
+          <p:cNvSpPr/>
+          <p:nvPr/>
+        </p:nvSpPr>
+        <p:spPr>
+          <a:xfrm>
+            <a:off x="0" y="5116068"/>
+            <a:ext cx="9144000" cy="27432"/>
+          </a:xfrm>
+          <a:prstGeom prst="rect">
+            <a:avLst/>
+          </a:prstGeom>
+          <a:solidFill>
+            <a:srgbClr val="E82127"/>
+          </a:solidFill>
+          <a:ln/>
+        </p:spPr>
+      </p:sp>
+      <p:sp>
+        <p:nvSpPr>
+          <p:cNvPr id="4" name="Text 2"/>
           <p:cNvSpPr/>
           <p:nvPr/>
         </p:nvSpPr>
@@ -8297,7 +8530,7 @@
       </p:sp>
       <p:sp>
         <p:nvSpPr>
-          <p:cNvPr id="4" name="Text 2"/>
+          <p:cNvPr id="5" name="Text 3"/>
           <p:cNvSpPr/>
           <p:nvPr/>
         </p:nvSpPr>
@@ -8328,7 +8561,7 @@
                 <a:ea typeface="Arial Black" pitchFamily="34" charset="-122"/>
                 <a:cs typeface="Arial Black" pitchFamily="34" charset="-120"/>
               </a:rPr>
-              <a:t>Executive Summary</a:t>
+              <a:t>References</a:t>
             </a:r>
             <a:endParaRPr lang="en-US" sz="2200" dirty="0"/>
           </a:p>
@@ -8336,14 +8569,53 @@
       </p:sp>
       <p:sp>
         <p:nvSpPr>
-          <p:cNvPr id="5" name="Shape 3"/>
+          <p:cNvPr id="6" name="Text 4"/>
+          <p:cNvSpPr/>
+          <p:nvPr/>
+        </p:nvSpPr>
+        <p:spPr>
+          <a:xfrm>
+            <a:off x="457200" y="868680"/>
+            <a:ext cx="7315200" cy="274320"/>
+          </a:xfrm>
+          <a:prstGeom prst="rect">
+            <a:avLst/>
+          </a:prstGeom>
+          <a:noFill/>
+          <a:ln/>
+        </p:spPr>
+        <p:txBody>
+          <a:bodyPr wrap="square" lIns="0" tIns="0" rIns="0" bIns="0" rtlCol="0" anchor="ctr"/>
+          <a:lstStyle/>
+          <a:p>
+            <a:pPr indent="0" marL="0">
+              <a:buNone/>
+            </a:pPr>
+            <a:r>
+              <a:rPr lang="en-US" sz="1000" i="1" dirty="0">
+                <a:solidFill>
+                  <a:srgbClr val="666677"/>
+                </a:solidFill>
+                <a:latin typeface="Georgia" pitchFamily="34" charset="0"/>
+                <a:ea typeface="Georgia" pitchFamily="34" charset="-122"/>
+                <a:cs typeface="Georgia" pitchFamily="34" charset="-120"/>
+              </a:rPr>
+              <a:t>Sources &amp; Citations</a:t>
+            </a:r>
+            <a:endParaRPr lang="en-US" sz="1000" dirty="0"/>
+          </a:p>
+        </p:txBody>
+      </p:sp>
+      <p:sp>
+        <p:nvSpPr>
+          <p:cNvPr id="7" name="Shape 5"/>
           <p:cNvSpPr/>
           <p:nvPr/>
         </p:nvSpPr>
         <p:spPr>
           <a:xfrm>
             <a:off x="457200" y="1188720"/>
-            <a:ext cx="8229600" cy="3657600"/>
+            <a:ext cx="8229600" cy="3200400"/>
           </a:xfrm>
           <a:prstGeom prst="rect">
             <a:avLst/>
@@ -8363,7 +8635,7 @@
       </p:sp>
       <p:sp>
         <p:nvSpPr>
-          <p:cNvPr id="6" name="Shape 4"/>
+          <p:cNvPr id="8" name="Shape 6"/>
           <p:cNvSpPr/>
           <p:nvPr/>
         </p:nvSpPr>
@@ -8383,7 +8655,7 @@
       </p:sp>
       <p:sp>
         <p:nvSpPr>
-          <p:cNvPr id="7" name="Text 5"/>
+          <p:cNvPr id="9" name="Text 7"/>
           <p:cNvSpPr/>
           <p:nvPr/>
         </p:nvSpPr>
@@ -8414,7 +8686,7 @@
                 <a:ea typeface="Arial" pitchFamily="34" charset="-122"/>
                 <a:cs typeface="Arial" pitchFamily="34" charset="-120"/>
               </a:rPr>
-              <a:t>Executive Summary</a:t>
+              <a:t>References</a:t>
             </a:r>
             <a:endParaRPr lang="en-US" sz="1000" dirty="0"/>
           </a:p>
@@ -8422,14 +8694,14 @@
       </p:sp>
       <p:sp>
         <p:nvSpPr>
-          <p:cNvPr id="8" name="Text 6"/>
+          <p:cNvPr id="10" name="Text 8"/>
           <p:cNvSpPr/>
           <p:nvPr/>
         </p:nvSpPr>
         <p:spPr>
           <a:xfrm>
             <a:off x="594360" y="1554480"/>
-            <a:ext cx="7955280" cy="3108960"/>
+            <a:ext cx="7955280" cy="2651760"/>
           </a:xfrm>
           <a:prstGeom prst="rect">
             <a:avLst/>
@@ -8441,335 +8713,130 @@
           <a:bodyPr wrap="square" lIns="0" tIns="0" rIns="0" bIns="0" rtlCol="0" anchor="ctr"/>
           <a:lstStyle/>
           <a:p>
-            <a:pPr indent="0" marL="0">
-              <a:buNone/>
-            </a:pPr>
-            <a:r>
-              <a:rPr lang="en-US" sz="900" dirty="0">
-                <a:solidFill>
-                  <a:srgbClr val="666677"/>
+            <a:pPr marL="342900" indent="-342900">
+              <a:buSzPct val="100000"/>
+              <a:buChar char="•"/>
+            </a:pPr>
+            <a:r>
+              <a:rPr lang="en-US" sz="700" dirty="0">
+                <a:solidFill>
+                  <a:srgbClr val="999999"/>
                 </a:solidFill>
                 <a:latin typeface="Arial" pitchFamily="34" charset="0"/>
                 <a:ea typeface="Arial" pitchFamily="34" charset="-122"/>
                 <a:cs typeface="Arial" pitchFamily="34" charset="-120"/>
               </a:rPr>
-              <a:t>(content to be added)</a:t>
-            </a:r>
-            <a:endParaRPr lang="en-US" sz="900" dirty="0"/>
-          </a:p>
-        </p:txBody>
-      </p:sp>
-    </p:spTree>
-  </p:cSld>
-  <p:clrMapOvr>
-    <a:masterClrMapping/>
-  </p:clrMapOvr>
-</p:sld>
-</file>
-
-<file path=ppt/slides/slide7.xml><?xml version="1.0" encoding="utf-8"?>
-<p:sld xmlns:a="http://schemas.openxmlformats.org/drawingml/2006/main" xmlns:r="http://schemas.openxmlformats.org/officeDocument/2006/relationships" xmlns:p="http://schemas.openxmlformats.org/presentationml/2006/main">
-  <p:cSld name="Slide 7">
-    <p:bg>
-      <p:bgPr>
-        <a:solidFill>
-          <a:srgbClr val="0A0A0F"/>
-        </a:solidFill>
-      </p:bgPr>
-    </p:bg>
-    <p:spTree>
-      <p:nvGrpSpPr>
-        <p:cNvPr id="1" name=""/>
-        <p:cNvGrpSpPr/>
-        <p:nvPr/>
-      </p:nvGrpSpPr>
-      <p:grpSpPr>
-        <a:xfrm>
-          <a:off x="0" y="0"/>
-          <a:ext cx="0" cy="0"/>
-          <a:chOff x="0" y="0"/>
-          <a:chExt cx="0" cy="0"/>
-        </a:xfrm>
-      </p:grpSpPr>
-      <p:sp>
-        <p:nvSpPr>
-          <p:cNvPr id="2" name="Shape 0"/>
-          <p:cNvSpPr/>
-          <p:nvPr/>
-        </p:nvSpPr>
-        <p:spPr>
-          <a:xfrm>
-            <a:off x="0" y="0"/>
-            <a:ext cx="9144000" cy="27432"/>
-          </a:xfrm>
-          <a:prstGeom prst="rect">
-            <a:avLst/>
-          </a:prstGeom>
-          <a:solidFill>
-            <a:srgbClr val="E82127"/>
-          </a:solidFill>
-          <a:ln/>
-        </p:spPr>
-      </p:sp>
-      <p:sp>
-        <p:nvSpPr>
-          <p:cNvPr id="3" name="Shape 1"/>
-          <p:cNvSpPr/>
-          <p:nvPr/>
-        </p:nvSpPr>
-        <p:spPr>
-          <a:xfrm>
-            <a:off x="0" y="5116068"/>
-            <a:ext cx="9144000" cy="27432"/>
-          </a:xfrm>
-          <a:prstGeom prst="rect">
-            <a:avLst/>
-          </a:prstGeom>
-          <a:solidFill>
-            <a:srgbClr val="E82127"/>
-          </a:solidFill>
-          <a:ln/>
-        </p:spPr>
-      </p:sp>
-      <p:sp>
-        <p:nvSpPr>
-          <p:cNvPr id="4" name="Text 2"/>
-          <p:cNvSpPr/>
-          <p:nvPr/>
-        </p:nvSpPr>
-        <p:spPr>
-          <a:xfrm>
-            <a:off x="457200" y="137160"/>
-            <a:ext cx="731520" cy="502920"/>
-          </a:xfrm>
-          <a:prstGeom prst="rect">
-            <a:avLst/>
-          </a:prstGeom>
-          <a:noFill/>
-          <a:ln/>
-        </p:spPr>
-        <p:txBody>
-          <a:bodyPr wrap="square" lIns="0" tIns="0" rIns="0" bIns="0" rtlCol="0" anchor="ctr"/>
-          <a:lstStyle/>
-          <a:p>
-            <a:pPr indent="0" marL="0">
-              <a:buNone/>
-            </a:pPr>
-            <a:r>
-              <a:rPr lang="en-US" sz="2800" dirty="0">
-                <a:solidFill>
-                  <a:srgbClr val="E82127"/>
-                </a:solidFill>
-                <a:latin typeface="Arial Black" pitchFamily="34" charset="0"/>
-                <a:ea typeface="Arial Black" pitchFamily="34" charset="-122"/>
-                <a:cs typeface="Arial Black" pitchFamily="34" charset="-120"/>
-              </a:rPr>
-              <a:t>06</a:t>
-            </a:r>
-            <a:endParaRPr lang="en-US" sz="2800" dirty="0"/>
-          </a:p>
-        </p:txBody>
-      </p:sp>
-      <p:sp>
-        <p:nvSpPr>
-          <p:cNvPr id="5" name="Text 3"/>
-          <p:cNvSpPr/>
-          <p:nvPr/>
-        </p:nvSpPr>
-        <p:spPr>
-          <a:xfrm>
-            <a:off x="457200" y="502920"/>
-            <a:ext cx="8229600" cy="411480"/>
-          </a:xfrm>
-          <a:prstGeom prst="rect">
-            <a:avLst/>
-          </a:prstGeom>
-          <a:noFill/>
-          <a:ln/>
-        </p:spPr>
-        <p:txBody>
-          <a:bodyPr wrap="square" lIns="0" tIns="0" rIns="0" bIns="0" rtlCol="0" anchor="ctr"/>
-          <a:lstStyle/>
-          <a:p>
-            <a:pPr indent="0" marL="0">
-              <a:buNone/>
-            </a:pPr>
-            <a:r>
-              <a:rPr lang="en-US" sz="2200" dirty="0">
-                <a:solidFill>
-                  <a:srgbClr val="F0F0F0"/>
-                </a:solidFill>
-                <a:latin typeface="Arial Black" pitchFamily="34" charset="0"/>
-                <a:ea typeface="Arial Black" pitchFamily="34" charset="-122"/>
-                <a:cs typeface="Arial Black" pitchFamily="34" charset="-120"/>
-              </a:rPr>
-              <a:t>References</a:t>
-            </a:r>
-            <a:endParaRPr lang="en-US" sz="2200" dirty="0"/>
-          </a:p>
-        </p:txBody>
-      </p:sp>
-      <p:sp>
-        <p:nvSpPr>
-          <p:cNvPr id="6" name="Text 4"/>
-          <p:cNvSpPr/>
-          <p:nvPr/>
-        </p:nvSpPr>
-        <p:spPr>
-          <a:xfrm>
-            <a:off x="457200" y="868680"/>
-            <a:ext cx="7315200" cy="274320"/>
-          </a:xfrm>
-          <a:prstGeom prst="rect">
-            <a:avLst/>
-          </a:prstGeom>
-          <a:noFill/>
-          <a:ln/>
-        </p:spPr>
-        <p:txBody>
-          <a:bodyPr wrap="square" lIns="0" tIns="0" rIns="0" bIns="0" rtlCol="0" anchor="ctr"/>
-          <a:lstStyle/>
-          <a:p>
-            <a:pPr indent="0" marL="0">
-              <a:buNone/>
-            </a:pPr>
-            <a:r>
-              <a:rPr lang="en-US" sz="1000" i="1" dirty="0">
-                <a:solidFill>
-                  <a:srgbClr val="666677"/>
-                </a:solidFill>
-                <a:latin typeface="Georgia" pitchFamily="34" charset="0"/>
-                <a:ea typeface="Georgia" pitchFamily="34" charset="-122"/>
-                <a:cs typeface="Georgia" pitchFamily="34" charset="-120"/>
-              </a:rPr>
-              <a:t>Sources &amp; Citations</a:t>
-            </a:r>
-            <a:endParaRPr lang="en-US" sz="1000" dirty="0"/>
-          </a:p>
-        </p:txBody>
-      </p:sp>
-      <p:sp>
-        <p:nvSpPr>
-          <p:cNvPr id="7" name="Shape 5"/>
-          <p:cNvSpPr/>
-          <p:nvPr/>
-        </p:nvSpPr>
-        <p:spPr>
-          <a:xfrm>
-            <a:off x="457200" y="1188720"/>
-            <a:ext cx="8229600" cy="3200400"/>
-          </a:xfrm>
-          <a:prstGeom prst="rect">
-            <a:avLst/>
-          </a:prstGeom>
-          <a:solidFill>
-            <a:srgbClr val="141420"/>
-          </a:solidFill>
-          <a:ln/>
-          <a:effectLst>
-            <a:outerShdw sx="100000" sy="100000" kx="0" ky="0" algn="bl" rotWithShape="0" blurRad="76200" dist="25400" dir="8100000">
-              <a:srgbClr val="000000">
-                <a:alpha val="35000"/>
-              </a:srgbClr>
-            </a:outerShdw>
-          </a:effectLst>
-        </p:spPr>
-      </p:sp>
-      <p:sp>
-        <p:nvSpPr>
-          <p:cNvPr id="8" name="Shape 6"/>
-          <p:cNvSpPr/>
-          <p:nvPr/>
-        </p:nvSpPr>
-        <p:spPr>
-          <a:xfrm>
-            <a:off x="457200" y="1188720"/>
-            <a:ext cx="8229600" cy="32004"/>
-          </a:xfrm>
-          <a:prstGeom prst="rect">
-            <a:avLst/>
-          </a:prstGeom>
-          <a:solidFill>
-            <a:srgbClr val="E82127"/>
-          </a:solidFill>
-          <a:ln/>
-        </p:spPr>
-      </p:sp>
-      <p:sp>
-        <p:nvSpPr>
-          <p:cNvPr id="9" name="Text 7"/>
-          <p:cNvSpPr/>
-          <p:nvPr/>
-        </p:nvSpPr>
-        <p:spPr>
-          <a:xfrm>
-            <a:off x="594360" y="1280160"/>
-            <a:ext cx="3657600" cy="201168"/>
-          </a:xfrm>
-          <a:prstGeom prst="rect">
-            <a:avLst/>
-          </a:prstGeom>
-          <a:noFill/>
-          <a:ln/>
-        </p:spPr>
-        <p:txBody>
-          <a:bodyPr wrap="square" lIns="0" tIns="0" rIns="0" bIns="0" rtlCol="0" anchor="ctr"/>
-          <a:lstStyle/>
-          <a:p>
-            <a:pPr indent="0" marL="0">
-              <a:buNone/>
-            </a:pPr>
-            <a:r>
-              <a:rPr lang="en-US" sz="1000" b="1" dirty="0">
-                <a:solidFill>
-                  <a:srgbClr val="E82127"/>
+              <a:t>Model 3 – sports electric sedan | Tesla. Available at: https://www.tesla.com/model3 (Accessed: 23 March 2026).</a:t>
+            </a:r>
+            <a:endParaRPr lang="en-US" sz="700" dirty="0"/>
+          </a:p>
+          <a:p>
+            <a:pPr marL="342900" indent="-342900">
+              <a:buSzPct val="100000"/>
+              <a:buChar char="•"/>
+            </a:pPr>
+            <a:r>
+              <a:rPr lang="en-US" sz="700" dirty="0">
+                <a:solidFill>
+                  <a:srgbClr val="999999"/>
                 </a:solidFill>
                 <a:latin typeface="Arial" pitchFamily="34" charset="0"/>
                 <a:ea typeface="Arial" pitchFamily="34" charset="-122"/>
                 <a:cs typeface="Arial" pitchFamily="34" charset="-120"/>
               </a:rPr>
-              <a:t>References</a:t>
-            </a:r>
-            <a:endParaRPr lang="en-US" sz="1000" dirty="0"/>
-          </a:p>
-        </p:txBody>
-      </p:sp>
-      <p:sp>
-        <p:nvSpPr>
-          <p:cNvPr id="10" name="Text 8"/>
-          <p:cNvSpPr/>
-          <p:nvPr/>
-        </p:nvSpPr>
-        <p:spPr>
-          <a:xfrm>
-            <a:off x="594360" y="1554480"/>
-            <a:ext cx="7955280" cy="2651760"/>
-          </a:xfrm>
-          <a:prstGeom prst="rect">
-            <a:avLst/>
-          </a:prstGeom>
-          <a:noFill/>
-          <a:ln/>
-        </p:spPr>
-        <p:txBody>
-          <a:bodyPr wrap="square" lIns="0" tIns="0" rIns="0" bIns="0" rtlCol="0" anchor="ctr"/>
-          <a:lstStyle/>
-          <a:p>
-            <a:pPr indent="0" marL="0">
-              <a:buNone/>
-            </a:pPr>
-            <a:r>
-              <a:rPr lang="en-US" sz="900" dirty="0">
-                <a:solidFill>
-                  <a:srgbClr val="666677"/>
+              <a:t>Admin (2025) Tesla’s marketing strategy and its impact on EV Growth, Aeternus. Available at: https://www.aeternus.rs/driving-innovation-teslas-marketing-strategy-and-its-impact-on-electric-vehicle-adoption/ (Accessed: 24 March 2026).</a:t>
+            </a:r>
+            <a:endParaRPr lang="en-US" sz="700" dirty="0"/>
+          </a:p>
+          <a:p>
+            <a:pPr marL="342900" indent="-342900">
+              <a:buSzPct val="100000"/>
+              <a:buChar char="•"/>
+            </a:pPr>
+            <a:r>
+              <a:rPr lang="en-US" sz="700" dirty="0">
+                <a:solidFill>
+                  <a:srgbClr val="999999"/>
                 </a:solidFill>
                 <a:latin typeface="Arial" pitchFamily="34" charset="0"/>
                 <a:ea typeface="Arial" pitchFamily="34" charset="-122"/>
                 <a:cs typeface="Arial" pitchFamily="34" charset="-120"/>
               </a:rPr>
-              <a:t>(content to be added)</a:t>
-            </a:r>
-            <a:endParaRPr lang="en-US" sz="900" dirty="0"/>
+              <a:t>Hu, J. (2025) ‘Research on the marketing strategy of Tesla marketing based on the 4P Theory and SWOT analytical method’, Advances in Economics, Management and Political Sciences, 240(1), pp. 81–90.</a:t>
+            </a:r>
+            <a:endParaRPr lang="en-US" sz="700" dirty="0"/>
+          </a:p>
+          <a:p>
+            <a:pPr marL="342900" indent="-342900">
+              <a:buSzPct val="100000"/>
+              <a:buChar char="•"/>
+            </a:pPr>
+            <a:r>
+              <a:rPr lang="en-US" sz="700" dirty="0">
+                <a:solidFill>
+                  <a:srgbClr val="999999"/>
+                </a:solidFill>
+                <a:latin typeface="Arial" pitchFamily="34" charset="0"/>
+                <a:ea typeface="Arial" pitchFamily="34" charset="-122"/>
+                <a:cs typeface="Arial" pitchFamily="34" charset="-120"/>
+              </a:rPr>
+              <a:t>Hu, Z. (2022) ‘Research on the consumer behavior characteristics and marketing strategy of new energy vehicles’, BCP Business &amp; Management, 31, pp. 168–175.</a:t>
+            </a:r>
+            <a:endParaRPr lang="en-US" sz="700" dirty="0"/>
+          </a:p>
+          <a:p>
+            <a:pPr marL="342900" indent="-342900">
+              <a:buSzPct val="100000"/>
+              <a:buChar char="•"/>
+            </a:pPr>
+            <a:r>
+              <a:rPr lang="en-US" sz="700" dirty="0">
+                <a:solidFill>
+                  <a:srgbClr val="999999"/>
+                </a:solidFill>
+                <a:latin typeface="Arial" pitchFamily="34" charset="0"/>
+                <a:ea typeface="Arial" pitchFamily="34" charset="-122"/>
+                <a:cs typeface="Arial" pitchFamily="34" charset="-120"/>
+              </a:rPr>
+              <a:t>Mangram, M.E. (2012) ‘The globalization of Tesla Motors: A strategic marketing plan analysis’, Journal of Strategic Marketing, 20(4), pp. 289–312.</a:t>
+            </a:r>
+            <a:endParaRPr lang="en-US" sz="700" dirty="0"/>
+          </a:p>
+          <a:p>
+            <a:pPr marL="342900" indent="-342900">
+              <a:buSzPct val="100000"/>
+              <a:buChar char="•"/>
+            </a:pPr>
+            <a:r>
+              <a:rPr lang="en-US" sz="700" dirty="0">
+                <a:solidFill>
+                  <a:srgbClr val="999999"/>
+                </a:solidFill>
+                <a:latin typeface="Arial" pitchFamily="34" charset="0"/>
+                <a:ea typeface="Arial" pitchFamily="34" charset="-122"/>
+                <a:cs typeface="Arial" pitchFamily="34" charset="-120"/>
+              </a:rPr>
+              <a:t>Young, J., Fattah, A. and Clark, P. (2020) Tesla: Direct Marketing Vs Franchising [Preprint].</a:t>
+            </a:r>
+            <a:endParaRPr lang="en-US" sz="700" dirty="0"/>
+          </a:p>
+          <a:p>
+            <a:pPr marL="342900" indent="-342900">
+              <a:buSzPct val="100000"/>
+              <a:buChar char="•"/>
+            </a:pPr>
+            <a:r>
+              <a:rPr lang="en-US" sz="700" dirty="0">
+                <a:solidFill>
+                  <a:srgbClr val="999999"/>
+                </a:solidFill>
+                <a:latin typeface="Arial" pitchFamily="34" charset="0"/>
+                <a:ea typeface="Arial" pitchFamily="34" charset="-122"/>
+                <a:cs typeface="Arial" pitchFamily="34" charset="-120"/>
+              </a:rPr>
+              <a:t>‘Tesla marketing analysis’ (2023) Academic Journal of Business &amp; Management, 5(2).</a:t>
+            </a:r>
+            <a:endParaRPr lang="en-US" sz="700" dirty="0"/>
           </a:p>
         </p:txBody>
       </p:sp>

</xml_diff>